<commit_message>
docs(report,deck): polish final-round report and slide deck
Report: adopt the hand-polished text as the source (docs/competition/FINAL_REPORT.md),
tighten remaining boilerplate, and fix numbers that changed after the reorganization
(8 run groups, 223 tool calls, 65 offline tests, r2 tag). DOCX builder now typesets
three-line tables with captions, hanging-indent lists, justified body text with a
2-character first-line indent, keep-with-next headings/figures, and no forced page
breaks (9 pages, no near-empty pages).

Deck: restore the formal-case slide set (BYZSO 51/51, 23 pages; LLZO 46/10) that the
report describes, keep the team/title cover, rewrite slide 12 as a balanced 2x2 grid
with a boundary strip that mentions the 09-03 supplementary runs, drop the cliché
title on slide 3 and the "3.8 kw" slang on the cover; speaker notes synced.
</commit_message>
<xml_diff>
--- a/submission/方案说明PPT/SAGE-Mat_复赛方案说明.pptx
+++ b/submission/方案说明PPT/SAGE-Mat_复赛方案说明.pptx
@@ -411,7 +411,7 @@
           <a:p>
             <a:r>
               <a:rPr lang="zh-CN" dirty="0"/>
-              <a:t>案例一展示的是文献丰富时如何避免“数字可比”的假象。最新版 LLZO 报告为十六页、十节，三百六十八条引用审计记录全部通过；正文使用二百一十二篇文献、三百七十八次引用调用，并包含三图、五表和两个显示公式。报告把组成、锂库存、致密化、界面与测量几何串成工艺—结构—输运链，提出锂活度交互图、等密度 Ta–LLZO 晶界研究和超快烧结后表面清理配对测试三项判别实验。模型给出的前驱体候选仍统一标记为待实验验证，不作为已经成立的化学结论。</a:t>
+              <a:t>初赛承诺的 LLZO 主题已经端到端跑通：四十六篇文献覆盖六个子主题，逐条核对通过，并整合成十页 A4 综述。模型首选前驱体路线是氧化锆、氧化镧和碳酸锂，与文献一致；次选出现可疑命名，反而说明模型生成、化学式规范化、文献复核和对抗审稿这四步把关非常必要。整轮共有二十一个 Agent 任务和四十九次工具调用，替代材料 Li6PS5Cl、Li3YCl6 和 LATP 的首选路线也都通过文献复核，分别对应高电导冷压、高电压正极侧和低成本空气中操作三种场景。</a:t>
             </a:r>
           </a:p>
         </p:txBody>
@@ -470,7 +470,7 @@
           <a:p>
             <a:r>
               <a:rPr lang="zh-CN" dirty="0"/>
-              <a:t>这一页用案例三展示可追溯链。编排器把七个子主题组织成十五批、二十四个任务 JSONL；检索从五百一十六条记录形成五百一十三条去重文献；引用核对逐条通过，写作得到三十五页终稿和七百五十七次正文引用。绘图保留三组 figspec、SVG 和 draw.io 同源产物，想法阶段生成三个研究提案及三个实验计划。终审没有 blocker 或 major，只有一项不影响科学结论的参考文献元数据 minor。所有数字都能回到 ledger、引用审计、工具日志和逐任务轨迹。</a:t>
+              <a:t>这一页回到冷启动输入：系统只接收一行主题，也就是 Ba 五 Y 十二 Zn 及其结构相近化合物的合成条件。编排器自动确认范围，四次在需要人确认的节点续跑，组织了二十九批、四十个子任务；文献检索覆盖八个子主题，在线五源加本地全文库得到六十三条候选。引用核对让五十一篇全部通过，写作完成十一章、二百一十九次引用和百分之百整合，绘图把三张视觉参照重建成可编辑图，想法生成调用 RECIPE 三次给出四个实验方向，对抗审稿两轮后首轮七项问题全部关闭、终审零问题。</a:t>
             </a:r>
           </a:p>
         </p:txBody>
@@ -529,7 +529,7 @@
           <a:p>
             <a:r>
               <a:rPr lang="zh-CN" dirty="0"/>
-              <a:t>复现不再只检查进程是否退出。依赖由 uv.lock 冻结，冒烟测试覆盖四个 MCP 服务和六十五项离线测试；核心复现脚本强制检查 PDF、BibTeX、引用审计、ledger、SVG、draw.io 和逐任务 JSONL，全部通过才生成复现收据。导出器还会扫描普通文本与压缩轨迹、规范化 JSONL，并在发现凭证或私有路径时拒绝打包。需要诚实说明的是，大模型步骤不可逐字复现，案例三的独立性仍是同模型冷启动 provisional，所有模型候选也都等待实验验证。</a:t>
+              <a:t>复现与开源。我们复用开源的 Codex CLI 作为 Agent 宿主，九个角色都写成可读的 Markdown 说明，模型和推理强度写进配置随包提交；自主设计并开源四个 MCP 服务，覆盖文献检索、引用核对、绘图和 RECIPE 前驱体预测，全部可离线测试，每次调用都有审计日志。知识库方面，被引的五十一篇文献中有二十一篇全文进入公开知识库，其余三十篇给出 DOI，在线检索不受影响。复现分三层：锁定依赖的一键安装，一两分钟、不联网也不调用大模型的冒烟测试，以及同一主题重跑整条流水线，所有质量关卡通过脚本才返回零。边界也说清楚：目标相只有一篇直接报道；大模型步骤不能逐字复现，我们以关卡全部通过作为复现判据。九月三日我们还用同一套系统对三个新主题各做了一次冷启动，产物全部随包提交。</a:t>
             </a:r>
           </a:p>
         </p:txBody>
@@ -588,7 +588,7 @@
           <a:p>
             <a:r>
               <a:rPr lang="zh-CN" dirty="0"/>
-              <a:t>最后是应用价值。这套系统真正改变的，是把“该不该相信这条结论”变成一个可以点开 DOI 和原文段落回答的问题。案例三在直接证据稀疏时完成五百一十三条文献的逐条核验，并把证据边界收敛为三个带失败判据的实验方向；LLZO 则在文献丰富时，用三百六十八条审计记录和统一比较字段识别工艺、结构与电导之间的混杂因素，再给出三项判别实验。对自动化实验室，我们交付的是可调度的前驱体、条件、表征和失败判据，实验结果可以同格式回写并触发下一轮迭代。下一步是引入跨模型独立审稿、执行两个案例的优先实验并回写证据，同时扩展温度和气氛条件预测。仓库以 MIT 协议开源。感谢各位评审。</a:t>
+              <a:t>最后是应用价值。这套系统真正改变的，是把"该不该相信这条结论"变成一个可以点开 DOI 和原文段落回答的问题。对材料研究者，一次运行替代数周的文献梳理，五十一篇文献逐条核对，二十八条合成条件逐字段比较，前人结论汇总之后可以直接进入课题设计。对自动化实验室，我们交付的是可执行的方案而不是一段总结：前驱体、条件、表征和失败判据都是结构化对象，实验结果同格式回写为证据，触发新一轮迭代，需要人确认的节点保留在回路中。对只有一篇报道的新化合物，系统也能从近邻体系推断可迁移的边界，给出四个实验方向和七种化合物的前驱体候选，把探索预算花在最有发现价值的地方。下一步我们会接入跨模型审稿，对四个方向开展合成实验并回写证据，整个仓库以 MIT 协议开源。感谢各位评审。</a:t>
             </a:r>
           </a:p>
         </p:txBody>
@@ -706,7 +706,7 @@
           <a:p>
             <a:r>
               <a:rPr lang="zh-CN" dirty="0"/>
-              <a:t>具体到科学问题。成功的合成条件和失败的边界都写在文献里，关键是用哪些、怎么找，以及找到之后哪里还有新的科学发现，也就是站在巨人的肩膀上继续前行。科学问题本身也是探索出来的：案例 A 是 LLZO 石榴石固态电解质，由团队在初赛调研中自主探索确定，文献很多，但没有人把它们整理成跨掺杂体系的统一工艺图景；案例 B 是专家推荐的 Ba5Y12Zn[O(SiO4)]8，2024 年首次报道，只有一篇直接合成文献，但近邻体系证据丰富。我们要回答的三个问题是：用哪些文献、怎么找到并核对、新发现在哪里。</a:t>
+              <a:t>具体到科学问题。成功的合成条件和失败的边界都写在文献里，关键是用哪些、怎么找，以及找到之后哪里还有新的科学发现，先把已有条件找全、核对清，再谈新发现。科学问题本身也是探索出来的：案例 A 是 LLZO 石榴石固态电解质，由团队在初赛调研中自主探索确定，文献很多，但没有人把它们整理成跨掺杂体系的统一工艺图景；案例 B 是专家推荐的 Ba5Y12Zn[O(SiO4)]8，2024 年首次报道，只有一篇直接合成文献，但近邻体系证据丰富。我们要回答的三个问题是：用哪些文献、怎么找到并核对、新发现在哪里。</a:t>
             </a:r>
           </a:p>
         </p:txBody>
@@ -1001,7 +1001,7 @@
           <a:p>
             <a:r>
               <a:rPr lang="zh-CN" dirty="0"/>
-              <a:t>最新正式案例是 Ba–Y–Zn–Si–O 硅酸盐的相图、合成与亚稳相问题。系统从一行主题出发，在直接证据稀疏的情况下形成三十五页终稿：五百一十三条文献记录全部通过审计，正文七百五十七次引用，整合率百分之百；三张图和三个实验设计分别保留可编辑图源与结构化计划。十五批、二十四个任务轨迹和四十二次工具调用全部留痕。格式终审没有 blocker 或 major，只保留一项参考文献元数据排版 minor。</a:t>
+              <a:t>正式案例是纯主题冷启动，唯一输入是一行关于 Ba 五 Y 十二 Zn 硅酸盐及其近邻化合物合成条件的主题。系统在需要人确认的节点续跑后交出二十页综述，再按材料专家八条意见修订为二十三页正式稿。五十一篇参考文献逐条核对通过，正文有二百一十九次引用，三张图都由同一图源生成可编辑版本，两轮对抗审稿的终审没有遗留问题。右侧的运行事实展示了这些过程都被完整记录。</a:t>
             </a:r>
           </a:p>
         </p:txBody>
@@ -1060,7 +1060,7 @@
           <a:p>
             <a:r>
               <a:rPr lang="zh-CN" dirty="0"/>
-              <a:t>案例三的结论不是给出一份看似确定的配方。五百一十三条核验文献仍不足以证明可复现的相纯 Ba–Y–Zn–Si–O 四元晶相，近邻体系只能支持结构、路线或热力学边界。为避免把邻近成功误写成目标证据，系统要求同时记录实际组成、前驱体、坩埚和气氛、热历史、相组成及不确定性，并提出三个可证伪方向：测量缺失的四元相图子空间，区分亚稳态与组成漂移，以及用盲测和重复样建立不确定性感知的闭环选点。</a:t>
+              <a:t>在科学结论上，系统给出的不是一份配方，而是文献证据限定的可迁移范围。公开证据只能确认目标相采用开放体系高温溶液法并以单晶衍射鉴定，不足以给出经验证的复现配方；无锌四方谱系提供了助熔生长、固相陶瓷和粉体相场筛查三类可比路线，但具体数值不能无条件迁移。获得单晶不等于建立批量相纯窗口，局部相图才是连接复现与发现的核心实验。基于这些边界，系统提出四个方向，每个方向都配了工艺路线和模型候选前驱体。</a:t>
             </a:r>
           </a:p>
         </p:txBody>
@@ -2415,7 +2415,7 @@
           <p:spPr>
             <a:xfrm>
               <a:off x="9010650" y="975360"/>
-              <a:ext cx="2739318" cy="819150"/>
+              <a:ext cx="2442481" cy="819150"/>
             </a:xfrm>
             <a:prstGeom prst="rect">
               <a:avLst/>
@@ -2441,7 +2441,7 @@
                   <a:ea typeface="Microsoft YaHei"/>
                   <a:cs typeface="Segoe UI"/>
                 </a:rPr>
-                <a:t>3.8 kw 篇</a:t>
+                <a:t>3,757 万</a:t>
               </a:r>
             </a:p>
           </p:txBody>
@@ -2455,7 +2455,7 @@
           <p:spPr>
             <a:xfrm>
               <a:off x="9022842" y="1587818"/>
-              <a:ext cx="2645474" cy="492633"/>
+              <a:ext cx="2499741" cy="492633"/>
             </a:xfrm>
             <a:prstGeom prst="rect">
               <a:avLst/>
@@ -2485,7 +2485,7 @@
                   <a:ea typeface="Microsoft YaHei"/>
                   <a:cs typeface="Segoe UI"/>
                 </a:rPr>
-                <a:t>本地文献全文库（约 3,757 万篇）</a:t>
+                <a:t>篇本地文献全文（1990s–2021）</a:t>
               </a:r>
               <a:r>
                 <a:rPr lang="zh-CN" sz="1350" dirty="0">
@@ -2946,9 +2946,9 @@
         <p:grpSpPr>
           <a:xfrm>
             <a:off x="670560" y="590550"/>
-            <a:ext cx="10246157" cy="586740"/>
+            <a:ext cx="12800076" cy="586740"/>
             <a:chOff x="670560" y="590550"/>
-            <a:chExt cx="10246157" cy="586740"/>
+            <a:chExt cx="12800076" cy="586740"/>
           </a:xfrm>
         </p:grpSpPr>
         <p:sp>
@@ -2960,7 +2960,7 @@
           <p:spPr>
             <a:xfrm>
               <a:off x="670560" y="590550"/>
-              <a:ext cx="10246157" cy="586740"/>
+              <a:ext cx="12800076" cy="586740"/>
             </a:xfrm>
             <a:prstGeom prst="rect">
               <a:avLst/>
@@ -2986,7 +2986,7 @@
                   <a:ea typeface="Microsoft YaHei"/>
                   <a:cs typeface="Segoe UI"/>
                 </a:rPr>
-                <a:t>LLZO 证据综合：三项判别实验贯通工艺—结构—电导</a:t>
+                <a:t>LLZO 主题端到端跑通：46 篇文献、10 页综述、路线与文献一致</a:t>
               </a:r>
             </a:p>
           </p:txBody>
@@ -3023,9 +3023,9 @@
         <p:grpSpPr>
           <a:xfrm>
             <a:off x="675894" y="1370648"/>
-            <a:ext cx="8935212" cy="743331"/>
+            <a:ext cx="9281922" cy="743331"/>
             <a:chOff x="675894" y="1370648"/>
-            <a:chExt cx="8935212" cy="743331"/>
+            <a:chExt cx="9281922" cy="743331"/>
           </a:xfrm>
         </p:grpSpPr>
         <p:sp>
@@ -3037,7 +3037,7 @@
           <p:spPr>
             <a:xfrm>
               <a:off x="675894" y="1370648"/>
-              <a:ext cx="8935212" cy="743331"/>
+              <a:ext cx="9281922" cy="743331"/>
             </a:xfrm>
             <a:prstGeom prst="rect">
               <a:avLst/>
@@ -3065,7 +3065,7 @@
                   <a:ea typeface="Microsoft YaHei"/>
                   <a:cs typeface="Segoe UI"/>
                 </a:rPr>
-                <a:t>文献丰富并不等于结果可比；最新终稿把组成、锂库存、致密化、界面与测量几何</a:t>
+                <a:t>初赛承诺的主题交出 46 篇文献、六个子主题覆盖与 10 页综述；模型首选前驱体路线</a:t>
               </a:r>
               <a:r>
                 <a:rPr lang="zh-CN" sz="1950" dirty="0">
@@ -3076,7 +3076,7 @@
                   <a:ea typeface="Microsoft YaHei"/>
                   <a:cs typeface="Segoe UI"/>
                 </a:rPr>
-                <a:t>串成</a:t>
+                <a:t>与文献一致，系统把每一步都留在</a:t>
               </a:r>
               <a:r>
                 <a:rPr lang="zh-CN" sz="1950" b="1" dirty="0">
@@ -3087,7 +3087,7 @@
                   <a:ea typeface="Microsoft YaHei"/>
                   <a:cs typeface="Segoe UI"/>
                 </a:rPr>
-                <a:t>工艺—结构—输运链</a:t>
+                <a:t>可追溯的质量回环</a:t>
               </a:r>
               <a:r>
                 <a:rPr lang="zh-CN" sz="1950" dirty="0">
@@ -3098,7 +3098,7 @@
                   <a:ea typeface="Microsoft YaHei"/>
                   <a:cs typeface="Segoe UI"/>
                 </a:rPr>
-                <a:t>，并给出统一的最小比较记录。</a:t>
+                <a:t>里。</a:t>
               </a:r>
             </a:p>
           </p:txBody>
@@ -3113,9 +3113,9 @@
         <p:grpSpPr>
           <a:xfrm>
             <a:off x="666750" y="2270760"/>
-            <a:ext cx="2824658" cy="2952941"/>
+            <a:ext cx="3426104" cy="2952941"/>
             <a:chOff x="666750" y="2270760"/>
-            <a:chExt cx="2824658" cy="2952941"/>
+            <a:chExt cx="3426104" cy="2952941"/>
           </a:xfrm>
         </p:grpSpPr>
         <p:sp>
@@ -3127,7 +3127,7 @@
           <p:spPr>
             <a:xfrm>
               <a:off x="666750" y="2270760"/>
-              <a:ext cx="2679950" cy="819150"/>
+              <a:ext cx="691142" cy="819150"/>
             </a:xfrm>
             <a:prstGeom prst="rect">
               <a:avLst/>
@@ -3153,7 +3153,7 @@
                   <a:ea typeface="Segoe UI"/>
                   <a:cs typeface="Segoe UI"/>
                 </a:rPr>
-                <a:t>368 / 368</a:t>
+                <a:t>46</a:t>
               </a:r>
             </a:p>
           </p:txBody>
@@ -3167,7 +3167,7 @@
           <p:spPr>
             <a:xfrm>
               <a:off x="678942" y="2864168"/>
-              <a:ext cx="2029968" cy="264033"/>
+              <a:ext cx="3103245" cy="264033"/>
             </a:xfrm>
             <a:prstGeom prst="rect">
               <a:avLst/>
@@ -3193,7 +3193,7 @@
                   <a:ea typeface="Microsoft YaHei"/>
                   <a:cs typeface="Segoe UI"/>
                 </a:rPr>
-                <a:t>引用审计记录全部 PASS</a:t>
+                <a:t>篇文献覆盖六个子主题，逐条核对通过</a:t>
               </a:r>
             </a:p>
           </p:txBody>
@@ -3207,7 +3207,7 @@
           <p:spPr>
             <a:xfrm>
               <a:off x="666750" y="3318510"/>
-              <a:ext cx="2679950" cy="819150"/>
+              <a:ext cx="2026909" cy="819150"/>
             </a:xfrm>
             <a:prstGeom prst="rect">
               <a:avLst/>
@@ -3233,7 +3233,7 @@
                   <a:ea typeface="Segoe UI"/>
                   <a:cs typeface="Segoe UI"/>
                 </a:rPr>
-                <a:t>212 · 378</a:t>
+                <a:t>21 · 49</a:t>
               </a:r>
             </a:p>
           </p:txBody>
@@ -3247,7 +3247,7 @@
           <p:spPr>
             <a:xfrm>
               <a:off x="678942" y="3911918"/>
-              <a:ext cx="2040084" cy="264033"/>
+              <a:ext cx="3413912" cy="264033"/>
             </a:xfrm>
             <a:prstGeom prst="rect">
               <a:avLst/>
@@ -3273,7 +3273,7 @@
                   <a:ea typeface="Microsoft YaHei"/>
                   <a:cs typeface="Segoe UI"/>
                 </a:rPr>
-                <a:t>篇正文文献 · 次引用调用</a:t>
+                <a:t>个 Agent 任务 · 次工具调用，全过程留痕</a:t>
               </a:r>
             </a:p>
           </p:txBody>
@@ -3313,7 +3313,7 @@
                   <a:ea typeface="Microsoft YaHei"/>
                   <a:cs typeface="Segoe UI"/>
                 </a:rPr>
-                <a:t>16 页</a:t>
+                <a:t>10 页</a:t>
               </a:r>
             </a:p>
           </p:txBody>
@@ -3327,7 +3327,7 @@
           <p:spPr>
             <a:xfrm>
               <a:off x="678942" y="4959668"/>
-              <a:ext cx="2812466" cy="264033"/>
+              <a:ext cx="2462022" cy="264033"/>
             </a:xfrm>
             <a:prstGeom prst="rect">
               <a:avLst/>
@@ -3353,7 +3353,7 @@
                   <a:ea typeface="Microsoft YaHei"/>
                   <a:cs typeface="Segoe UI"/>
                 </a:rPr>
-                <a:t>10 节 · 3 图 · 5 表 · 2 个显示公式</a:t>
+                <a:t>A4 综述 PDF，46 篇全部整合</a:t>
               </a:r>
             </a:p>
           </p:txBody>
@@ -3368,9 +3368,9 @@
         <p:grpSpPr>
           <a:xfrm>
             <a:off x="685800" y="5391150"/>
-            <a:ext cx="4506278" cy="762000"/>
+            <a:ext cx="4267200" cy="762000"/>
             <a:chOff x="685800" y="5391150"/>
-            <a:chExt cx="4506278" cy="762000"/>
+            <a:chExt cx="4267200" cy="762000"/>
           </a:xfrm>
         </p:grpSpPr>
         <p:sp>
@@ -3426,7 +3426,7 @@
           <p:spPr>
             <a:xfrm>
               <a:off x="907542" y="5531168"/>
-              <a:ext cx="3712064" cy="264033"/>
+              <a:ext cx="3971965" cy="264033"/>
             </a:xfrm>
             <a:prstGeom prst="rect">
               <a:avLst/>
@@ -3452,18 +3452,29 @@
                   <a:ea typeface="Microsoft YaHei"/>
                   <a:cs typeface="Segoe UI"/>
                 </a:rPr>
-                <a:t>核心产出</a:t>
-              </a:r>
-              <a:r>
-                <a:rPr lang="zh-CN" sz="1350" dirty="0">
+                <a:t>首选路线</a:t>
+              </a:r>
+              <a:r>
+                <a:rPr lang="en-US" sz="1350" dirty="0">
                   <a:solidFill>
                     <a:schemeClr val="dk1"/>
                   </a:solidFill>
                   <a:latin typeface="Segoe UI"/>
-                  <a:ea typeface="Microsoft YaHei"/>
-                  <a:cs typeface="Segoe UI"/>
-                </a:rPr>
-                <a:t xml:space="preserve"> 3 个研究提案 + 3 个结构化实验计划</a:t>
+                  <a:ea typeface="Segoe UI"/>
+                  <a:cs typeface="Segoe UI"/>
+                </a:rPr>
+                <a:t xml:space="preserve"> ZrO2 + La2O3 + Li2CO3 </a:t>
+              </a:r>
+              <a:r>
+                <a:rPr lang="zh-CN" sz="1350" b="1" dirty="0">
+                  <a:solidFill>
+                    <a:srgbClr val="2E7D32"/>
+                  </a:solidFill>
+                  <a:latin typeface="Segoe UI"/>
+                  <a:ea typeface="Microsoft YaHei"/>
+                  <a:cs typeface="Segoe UI"/>
+                </a:rPr>
+                <a:t>与文献一致</a:t>
               </a:r>
             </a:p>
           </p:txBody>
@@ -3477,7 +3488,7 @@
           <p:spPr>
             <a:xfrm>
               <a:off x="907542" y="5816918"/>
-              <a:ext cx="4284536" cy="264033"/>
+              <a:ext cx="3557588" cy="264033"/>
             </a:xfrm>
             <a:prstGeom prst="rect">
               <a:avLst/>
@@ -3503,7 +3514,7 @@
                   <a:ea typeface="Microsoft YaHei"/>
                   <a:cs typeface="Segoe UI"/>
                 </a:rPr>
-                <a:t>模型边界</a:t>
+                <a:t>质量把关</a:t>
               </a:r>
               <a:r>
                 <a:rPr lang="zh-CN" sz="1350" dirty="0">
@@ -3514,7 +3525,7 @@
                   <a:ea typeface="Microsoft YaHei"/>
                   <a:cs typeface="Segoe UI"/>
                 </a:rPr>
-                <a:t xml:space="preserve"> 前驱体候选均待实验验证，不作为化学结论</a:t>
+                <a:t xml:space="preserve"> 次选命名可疑，持续执行四步核对</a:t>
               </a:r>
             </a:p>
           </p:txBody>
@@ -3672,7 +3683,7 @@
           <p:spPr>
             <a:xfrm>
               <a:off x="5877306" y="2453640"/>
-              <a:ext cx="3834765" cy="352044"/>
+              <a:ext cx="3325901" cy="352044"/>
             </a:xfrm>
             <a:prstGeom prst="rect">
               <a:avLst/>
@@ -3698,7 +3709,7 @@
                   <a:ea typeface="Microsoft YaHei"/>
                   <a:cs typeface="Segoe UI"/>
                 </a:rPr>
-                <a:t>为什么不能只比较一个电导率数字</a:t>
+                <a:t>四步把关，让模型建议可审查</a:t>
               </a:r>
             </a:p>
           </p:txBody>
@@ -3712,7 +3723,7 @@
           <p:spPr>
             <a:xfrm>
               <a:off x="5517642" y="2902268"/>
-              <a:ext cx="4445698" cy="1407033"/>
+              <a:ext cx="4694301" cy="1407033"/>
             </a:xfrm>
             <a:prstGeom prst="rect">
               <a:avLst/>
@@ -3746,7 +3757,7 @@
                   <a:ea typeface="Microsoft YaHei"/>
                   <a:cs typeface="Segoe UI"/>
                 </a:rPr>
-                <a:t>掺杂与锂库存共同改变相稳定性和载流子占位</a:t>
+                <a:t>模型首选前驱体路线 ZrO2 + La2O3 + Li2CO3 与文献一致</a:t>
               </a:r>
             </a:p>
             <a:p>
@@ -3770,7 +3781,7 @@
                   <a:ea typeface="Microsoft YaHei"/>
                   <a:cs typeface="Segoe UI"/>
                 </a:rPr>
-                <a:t>前驱体与生坯历史决定反应尺度，烧结决定锂损失与晶界</a:t>
+                <a:t>系统始终坚持：模型生成 → 化学式规范化 → 文献复核 → 审稿</a:t>
               </a:r>
             </a:p>
             <a:p>
@@ -3794,7 +3805,7 @@
                   <a:ea typeface="Microsoft YaHei"/>
                   <a:cs typeface="Segoe UI"/>
                 </a:rPr>
-                <a:t>电极、压力、厚度与拟合模型会改变“测得的电导率”</a:t>
+                <a:t>次选命名可疑也不直接采信，四步把关</a:t>
               </a:r>
             </a:p>
             <a:p>
@@ -3818,7 +3829,7 @@
                   <a:ea typeface="Microsoft YaHei"/>
                   <a:cs typeface="Segoe UI"/>
                 </a:rPr>
-                <a:t>不控制密度和测量几何，就不能公平排名不同路线</a:t>
+                <a:t>多源检索 + 逐条核对，模型与文献互证</a:t>
               </a:r>
             </a:p>
             <a:p>
@@ -3842,7 +3853,7 @@
                   <a:ea typeface="Microsoft YaHei"/>
                   <a:cs typeface="Segoe UI"/>
                 </a:rPr>
-                <a:t>当前证据不支持完整 LLZO 相图或通用最佳路线</a:t>
+                <a:t>每一步可追溯，建议不被直接采信</a:t>
               </a:r>
             </a:p>
           </p:txBody>
@@ -3857,9 +3868,9 @@
         <p:grpSpPr>
           <a:xfrm>
             <a:off x="5289042" y="5626418"/>
-            <a:ext cx="4642866" cy="511683"/>
+            <a:ext cx="5560124" cy="511683"/>
             <a:chOff x="5289042" y="5626418"/>
-            <a:chExt cx="4642866" cy="511683"/>
+            <a:chExt cx="5560124" cy="511683"/>
           </a:xfrm>
         </p:grpSpPr>
         <p:sp>
@@ -3871,7 +3882,7 @@
           <p:spPr>
             <a:xfrm>
               <a:off x="5289042" y="5626418"/>
-              <a:ext cx="4642866" cy="511683"/>
+              <a:ext cx="5560124" cy="511683"/>
             </a:xfrm>
             <a:prstGeom prst="rect">
               <a:avLst/>
@@ -3899,7 +3910,7 @@
                   <a:ea typeface="Microsoft YaHei"/>
                   <a:cs typeface="Segoe UI"/>
                 </a:rPr>
-                <a:t>三项判别实验</a:t>
+                <a:t>替代材料分析</a:t>
               </a:r>
               <a:r>
                 <a:rPr lang="zh-CN" sz="1350" dirty="0">
@@ -3910,7 +3921,7 @@
                   <a:ea typeface="Microsoft YaHei"/>
                   <a:cs typeface="Segoe UI"/>
                 </a:rPr>
-                <a:t xml:space="preserve"> 锂活度交互图 · 等密度 Ta–LLZO 晶界研究 ·</a:t>
+                <a:t xml:space="preserve"> Li6PS5Cl、Li3YCl6、LATP 的模型首选路线均通过文献复核</a:t>
               </a:r>
               <a:r>
                 <a:rPr lang="zh-CN" sz="1350" dirty="0">
@@ -3921,7 +3932,7 @@
                   <a:ea typeface="Microsoft YaHei"/>
                   <a:cs typeface="Segoe UI"/>
                 </a:rPr>
-                <a:t>超快烧结后表面清理的配对样本测试；每项均预设失败判据。</a:t>
+                <a:t>分别对应高电导冷压、高电压正极侧、低成本空气中操作三种场景。</a:t>
               </a:r>
             </a:p>
           </p:txBody>
@@ -4067,9 +4078,9 @@
         <p:grpSpPr>
           <a:xfrm>
             <a:off x="670560" y="590550"/>
-            <a:ext cx="10080536" cy="586740"/>
+            <a:ext cx="9359646" cy="586740"/>
             <a:chOff x="670560" y="590550"/>
-            <a:chExt cx="10080536" cy="586740"/>
+            <a:chExt cx="9359646" cy="586740"/>
           </a:xfrm>
         </p:grpSpPr>
         <p:sp>
@@ -4081,7 +4092,7 @@
           <p:spPr>
             <a:xfrm>
               <a:off x="670560" y="590550"/>
-              <a:ext cx="10080536" cy="586740"/>
+              <a:ext cx="9359646" cy="586740"/>
             </a:xfrm>
             <a:prstGeom prst="rect">
               <a:avLst/>
@@ -4107,7 +4118,7 @@
                   <a:ea typeface="Microsoft YaHei"/>
                   <a:cs typeface="Segoe UI"/>
                 </a:rPr>
-                <a:t>从一行主题到 35 页终稿：每个角色都有可核对交付物</a:t>
+                <a:t>冷启动只输入一行主题，各类角色各自交出了什么</a:t>
               </a:r>
             </a:p>
           </p:txBody>
@@ -4144,9 +4155,9 @@
         <p:grpSpPr>
           <a:xfrm>
             <a:off x="675894" y="1370648"/>
-            <a:ext cx="7934458" cy="381381"/>
+            <a:ext cx="7632573" cy="381381"/>
             <a:chOff x="675894" y="1370648"/>
-            <a:chExt cx="7934458" cy="381381"/>
+            <a:chExt cx="7632573" cy="381381"/>
           </a:xfrm>
         </p:grpSpPr>
         <p:sp>
@@ -4158,7 +4169,7 @@
           <p:spPr>
             <a:xfrm>
               <a:off x="675894" y="1370648"/>
-              <a:ext cx="7934458" cy="381381"/>
+              <a:ext cx="7632573" cy="381381"/>
             </a:xfrm>
             <a:prstGeom prst="rect">
               <a:avLst/>
@@ -4184,7 +4195,7 @@
                   <a:ea typeface="Microsoft YaHei"/>
                   <a:cs typeface="Segoe UI"/>
                 </a:rPr>
-                <a:t>以案例 3 为例：检索、核对、写作、绘图、实验设计和审稿均落盘。</a:t>
+                <a:t>唯一输入是一行主题，下面展示各角色交付的亮点与可核对结果。</a:t>
               </a:r>
             </a:p>
           </p:txBody>
@@ -4297,7 +4308,7 @@
           <p:spPr>
             <a:xfrm>
               <a:off x="905256" y="2301240"/>
-              <a:ext cx="6001979" cy="352044"/>
+              <a:ext cx="7323201" cy="352044"/>
             </a:xfrm>
             <a:prstGeom prst="rect">
               <a:avLst/>
@@ -4323,7 +4334,7 @@
                   <a:ea typeface="Microsoft YaHei"/>
                   <a:cs typeface="Segoe UI"/>
                 </a:rPr>
-                <a:t>Ba–Y–Zn–Si–O 硅酸盐：相图导向的合成与亚稳相问题</a:t>
+                <a:t>调研主题：Ba5Y12Zn[O(SiO4)]8及其结构相近化合物的合成条件</a:t>
               </a:r>
             </a:p>
           </p:txBody>
@@ -4436,7 +4447,7 @@
           <p:spPr>
             <a:xfrm>
               <a:off x="907542" y="3245168"/>
-              <a:ext cx="3103245" cy="264033"/>
+              <a:ext cx="3675717" cy="264033"/>
             </a:xfrm>
             <a:prstGeom prst="rect">
               <a:avLst/>
@@ -4462,7 +4473,7 @@
                   <a:ea typeface="Microsoft YaHei"/>
                   <a:cs typeface="Segoe UI"/>
                 </a:rPr>
-                <a:t>七个子主题，范围与证据转移边界明确</a:t>
+                <a:t>自动确认范围；在需要人确认的节点续跑 4 次</a:t>
               </a:r>
             </a:p>
           </p:txBody>
@@ -4476,7 +4487,7 @@
           <p:spPr>
             <a:xfrm>
               <a:off x="907542" y="3473768"/>
-              <a:ext cx="3700577" cy="264033"/>
+              <a:ext cx="3712064" cy="264033"/>
             </a:xfrm>
             <a:prstGeom prst="rect">
               <a:avLst/>
@@ -4502,7 +4513,7 @@
                   <a:ea typeface="Microsoft YaHei"/>
                   <a:cs typeface="Segoe UI"/>
                 </a:rPr>
-                <a:t>15 批 / 24 个任务 JSONL，异常与重试保留</a:t>
+                <a:t>29 批 / 40 个子任务，约 7,084 万输入 token</a:t>
               </a:r>
             </a:p>
           </p:txBody>
@@ -4600,7 +4611,7 @@
           <p:spPr>
             <a:xfrm>
               <a:off x="6432042" y="3245168"/>
-              <a:ext cx="3702977" cy="264033"/>
+              <a:ext cx="2921508" cy="264033"/>
             </a:xfrm>
             <a:prstGeom prst="rect">
               <a:avLst/>
@@ -4626,7 +4637,7 @@
                   <a:ea typeface="Microsoft YaHei"/>
                   <a:cs typeface="Segoe UI"/>
                 </a:rPr>
-                <a:t>在线多源 + 本地全文库，近邻 / 相图专项补检</a:t>
+                <a:t>8 个子主题；在线五源 + 本地全文库</a:t>
               </a:r>
             </a:p>
           </p:txBody>
@@ -4640,7 +4651,7 @@
           <p:spPr>
             <a:xfrm>
               <a:off x="6432042" y="3473768"/>
-              <a:ext cx="3139592" cy="264033"/>
+              <a:ext cx="1176833" cy="264033"/>
             </a:xfrm>
             <a:prstGeom prst="rect">
               <a:avLst/>
@@ -4666,7 +4677,7 @@
                   <a:ea typeface="Microsoft YaHei"/>
                   <a:cs typeface="Segoe UI"/>
                 </a:rPr>
-                <a:t>516 条检索记录，形成 513 条去重文献</a:t>
+                <a:t>63 条候选文献</a:t>
               </a:r>
             </a:p>
           </p:txBody>
@@ -4779,7 +4790,7 @@
           <p:spPr>
             <a:xfrm>
               <a:off x="907542" y="4292918"/>
-              <a:ext cx="2366010" cy="264033"/>
+              <a:ext cx="3330416" cy="264033"/>
             </a:xfrm>
             <a:prstGeom prst="rect">
               <a:avLst/>
@@ -4805,7 +4816,7 @@
                   <a:ea typeface="Microsoft YaHei"/>
                   <a:cs typeface="Segoe UI"/>
                 </a:rPr>
-                <a:t>513 / 513 条引用记录 PASS</a:t>
+                <a:t>51 篇全部通过；5 条作者名不匹配的文献</a:t>
               </a:r>
             </a:p>
           </p:txBody>
@@ -4819,7 +4830,7 @@
           <p:spPr>
             <a:xfrm>
               <a:off x="907542" y="4521518"/>
-              <a:ext cx="3648456" cy="264033"/>
+              <a:ext cx="2376297" cy="264033"/>
             </a:xfrm>
             <a:prstGeom prst="rect">
               <a:avLst/>
@@ -4845,7 +4856,7 @@
                   <a:ea typeface="Microsoft YaHei"/>
                   <a:cs typeface="Segoe UI"/>
                 </a:rPr>
-                <a:t>存在性、元数据、作者顺序与引用解析可复查</a:t>
+                <a:t>三轮未收敛，交人决定后删除</a:t>
               </a:r>
             </a:p>
           </p:txBody>
@@ -4943,7 +4954,7 @@
           <p:spPr>
             <a:xfrm>
               <a:off x="6432042" y="4292918"/>
-              <a:ext cx="3112332" cy="264033"/>
+              <a:ext cx="2748858" cy="264033"/>
             </a:xfrm>
             <a:prstGeom prst="rect">
               <a:avLst/>
@@ -4969,7 +4980,7 @@
                   <a:ea typeface="Microsoft YaHei"/>
                   <a:cs typeface="Segoe UI"/>
                 </a:rPr>
-                <a:t>35 页、757 次正文引用、整合率 100%</a:t>
+                <a:t>11 章、219 次引用、整合率 100%</a:t>
               </a:r>
             </a:p>
           </p:txBody>
@@ -4983,7 +4994,7 @@
           <p:spPr>
             <a:xfrm>
               <a:off x="6432042" y="4521518"/>
-              <a:ext cx="3284982" cy="264033"/>
+              <a:ext cx="2739771" cy="264033"/>
             </a:xfrm>
             <a:prstGeom prst="rect">
               <a:avLst/>
@@ -5009,7 +5020,7 @@
                   <a:ea typeface="Microsoft YaHei"/>
                   <a:cs typeface="Segoe UI"/>
                 </a:rPr>
-                <a:t>直接证据、近邻类比和模型候选分层陈述</a:t>
+                <a:t>同类体系单独成节，前人结论汇总</a:t>
               </a:r>
             </a:p>
           </p:txBody>
@@ -5122,7 +5133,7 @@
           <p:spPr>
             <a:xfrm>
               <a:off x="907542" y="5340668"/>
-              <a:ext cx="3044202" cy="264033"/>
+              <a:ext cx="2712510" cy="264033"/>
             </a:xfrm>
             <a:prstGeom prst="rect">
               <a:avLst/>
@@ -5148,7 +5159,7 @@
                   <a:ea typeface="Microsoft YaHei"/>
                   <a:cs typeface="Segoe UI"/>
                 </a:rPr>
-                <a:t>3 张图保持 figspec / SVG / draw.io</a:t>
+                <a:t>3 张图先生成视觉参照，再重建为</a:t>
               </a:r>
             </a:p>
           </p:txBody>
@@ -5162,7 +5173,7 @@
           <p:spPr>
             <a:xfrm>
               <a:off x="907542" y="5569268"/>
-              <a:ext cx="2921508" cy="264033"/>
+              <a:ext cx="2376297" cy="264033"/>
             </a:xfrm>
             <a:prstGeom prst="rect">
               <a:avLst/>
@@ -5188,7 +5199,7 @@
                   <a:ea typeface="Microsoft YaHei"/>
                   <a:cs typeface="Segoe UI"/>
                 </a:rPr>
-                <a:t>同源一致，公式与连接关系检查通过</a:t>
+                <a:t>可编辑图，全部通过排版检查</a:t>
               </a:r>
             </a:p>
           </p:txBody>
@@ -5286,7 +5297,7 @@
           <p:spPr>
             <a:xfrm>
               <a:off x="4603242" y="5340668"/>
-              <a:ext cx="2349036" cy="264033"/>
+              <a:ext cx="2912335" cy="264033"/>
             </a:xfrm>
             <a:prstGeom prst="rect">
               <a:avLst/>
@@ -5312,7 +5323,7 @@
                   <a:ea typeface="Microsoft YaHei"/>
                   <a:cs typeface="Segoe UI"/>
                 </a:rPr>
-                <a:t>3 个研究提案 + 3 个实验计划</a:t>
+                <a:t>调用 RECIPE 3 次（Zn / Mg / Co）</a:t>
               </a:r>
             </a:p>
           </p:txBody>
@@ -5326,7 +5337,7 @@
           <p:spPr>
             <a:xfrm>
               <a:off x="4603242" y="5569268"/>
-              <a:ext cx="2576208" cy="264033"/>
+              <a:ext cx="2558034" cy="264033"/>
             </a:xfrm>
             <a:prstGeom prst="rect">
               <a:avLst/>
@@ -5352,7 +5363,7 @@
                   <a:ea typeface="Microsoft YaHei"/>
                   <a:cs typeface="Segoe UI"/>
                 </a:rPr>
-                <a:t>模型候选统一标记“待实验验证”</a:t>
+                <a:t>给出四个实验方向及前驱体候选</a:t>
               </a:r>
             </a:p>
           </p:txBody>
@@ -5450,7 +5461,7 @@
           <p:spPr>
             <a:xfrm>
               <a:off x="8298942" y="5340668"/>
-              <a:ext cx="2458079" cy="264033"/>
+              <a:ext cx="2403558" cy="264033"/>
             </a:xfrm>
             <a:prstGeom prst="rect">
               <a:avLst/>
@@ -5476,7 +5487,7 @@
                   <a:ea typeface="Microsoft YaHei"/>
                   <a:cs typeface="Segoe UI"/>
                 </a:rPr>
-                <a:t>格式终审 0 blocker / 0 major</a:t>
+                <a:t>两轮；首轮 7 项问题全部关闭</a:t>
               </a:r>
             </a:p>
           </p:txBody>
@@ -5490,7 +5501,7 @@
           <p:spPr>
             <a:xfrm>
               <a:off x="8298942" y="5569268"/>
-              <a:ext cx="2403558" cy="264033"/>
+              <a:ext cx="949662" cy="264033"/>
             </a:xfrm>
             <a:prstGeom prst="rect">
               <a:avLst/>
@@ -5516,7 +5527,7 @@
                   <a:ea typeface="Microsoft YaHei"/>
                   <a:cs typeface="Segoe UI"/>
                 </a:rPr>
-                <a:t>仅 1 个参考文献元数据 minor</a:t>
+                <a:t>终审 0 问题</a:t>
               </a:r>
             </a:p>
           </p:txBody>
@@ -5581,7 +5592,7 @@
           <p:spPr>
             <a:xfrm>
               <a:off x="679704" y="6156960"/>
-              <a:ext cx="6645592" cy="234696"/>
+              <a:ext cx="6958584" cy="234696"/>
             </a:xfrm>
             <a:prstGeom prst="rect">
               <a:avLst/>
@@ -5607,7 +5618,7 @@
                   <a:ea typeface="Microsoft YaHei"/>
                   <a:cs typeface="Segoe UI"/>
                 </a:rPr>
-                <a:t>每一项数字都能回到 ledger、CITATION_AUDIT、tool_calls、逐任务 JSONL 与最终 PDF。</a:t>
+                <a:t>七类角色共同交付：从一行主题开始，把检索、核对、写作、绘图、想法与审稿串成可复查结果。</a:t>
               </a:r>
             </a:p>
           </p:txBody>
@@ -5753,9 +5764,9 @@
         <p:grpSpPr>
           <a:xfrm>
             <a:off x="670560" y="590550"/>
-            <a:ext cx="9826104" cy="586740"/>
+            <a:ext cx="10815973" cy="586740"/>
             <a:chOff x="670560" y="590550"/>
-            <a:chExt cx="9826104" cy="586740"/>
+            <a:chExt cx="10815973" cy="586740"/>
           </a:xfrm>
         </p:grpSpPr>
         <p:sp>
@@ -5767,7 +5778,7 @@
           <p:spPr>
             <a:xfrm>
               <a:off x="670560" y="590550"/>
-              <a:ext cx="9826104" cy="586740"/>
+              <a:ext cx="10815973" cy="586740"/>
             </a:xfrm>
             <a:prstGeom prst="rect">
               <a:avLst/>
@@ -5793,7 +5804,7 @@
                   <a:ea typeface="Microsoft YaHei"/>
                   <a:cs typeface="Segoe UI"/>
                 </a:rPr>
-                <a:t>复现不是“能启动”：产物、闸门与轨迹必须同时通过</a:t>
+                <a:t>复现与开源：Codex 宿主 + 自研 MCP，仓库 MIT 全开源</a:t>
               </a:r>
             </a:p>
           </p:txBody>
@@ -5830,9 +5841,9 @@
         <p:grpSpPr>
           <a:xfrm>
             <a:off x="675894" y="1370648"/>
-            <a:ext cx="8043672" cy="743331"/>
+            <a:ext cx="10421112" cy="724281"/>
             <a:chOff x="675894" y="1370648"/>
-            <a:chExt cx="8043672" cy="743331"/>
+            <a:chExt cx="10421112" cy="724281"/>
           </a:xfrm>
         </p:grpSpPr>
         <p:sp>
@@ -5844,7 +5855,7 @@
           <p:spPr>
             <a:xfrm>
               <a:off x="675894" y="1370648"/>
-              <a:ext cx="8043672" cy="743331"/>
+              <a:ext cx="10421112" cy="724281"/>
             </a:xfrm>
             <a:prstGeom prst="rect">
               <a:avLst/>
@@ -5860,7 +5871,7 @@
             <a:p>
               <a:pPr algn="l">
                 <a:lnSpc>
-                  <a:spcPts val="2850"/>
+                  <a:spcPts val="2700"/>
                 </a:lnSpc>
               </a:pPr>
               <a:r>
@@ -5872,7 +5883,18 @@
                   <a:ea typeface="Microsoft YaHei"/>
                   <a:cs typeface="Segoe UI"/>
                 </a:rPr>
-                <a:t>安装锁定、65 项离线测试、核心结果复跑与导出安全扫描形成四层收据；</a:t>
+                <a:t>复现不靠截图：可读的角色说明、可运行的工具和开源产物，加上同一主题可重跑整条流水线，</a:t>
+              </a:r>
+              <a:r>
+                <a:rPr lang="zh-CN" sz="1950" b="1" dirty="0">
+                  <a:solidFill>
+                    <a:schemeClr val="accent2"/>
+                  </a:solidFill>
+                  <a:latin typeface="Segoe UI"/>
+                  <a:ea typeface="Microsoft YaHei"/>
+                  <a:cs typeface="Segoe UI"/>
+                </a:rPr>
+                <a:t>全部质量关卡通过</a:t>
               </a:r>
               <a:r>
                 <a:rPr lang="zh-CN" sz="1950" dirty="0">
@@ -5883,406 +5905,7 @@
                   <a:ea typeface="Microsoft YaHei"/>
                   <a:cs typeface="Segoe UI"/>
                 </a:rPr>
-                <a:t>任一必要产物缺失或质量关卡失败，脚本返回非零。</a:t>
-              </a:r>
-            </a:p>
-          </p:txBody>
-        </p:sp>
-      </p:grpSp>
-      <p:grpSp>
-        <p:nvGrpSpPr>
-          <p:cNvPr id="16" name="Group 16"/>
-          <p:cNvGrpSpPr/>
-          <p:nvPr/>
-        </p:nvGrpSpPr>
-        <p:grpSpPr>
-          <a:xfrm>
-            <a:off x="685800" y="2190750"/>
-            <a:ext cx="5295900" cy="3829050"/>
-            <a:chOff x="685800" y="2190750"/>
-            <a:chExt cx="5295900" cy="3829050"/>
-          </a:xfrm>
-        </p:grpSpPr>
-        <p:sp>
-          <p:nvSpPr>
-            <p:cNvPr id="7" name="Rectangle 7"/>
-            <p:cNvSpPr/>
-            <p:nvPr/>
-          </p:nvSpPr>
-          <p:spPr>
-            <a:xfrm>
-              <a:off x="685800" y="2190750"/>
-              <a:ext cx="5295900" cy="3829050"/>
-            </a:xfrm>
-            <a:prstGeom prst="rect">
-              <a:avLst/>
-            </a:prstGeom>
-            <a:solidFill>
-              <a:schemeClr val="lt2"/>
-            </a:solidFill>
-            <a:ln>
-              <a:noFill/>
-            </a:ln>
-          </p:spPr>
-        </p:sp>
-        <p:sp>
-          <p:nvSpPr>
-            <p:cNvPr id="8" name="TextBox 8"/>
-            <p:cNvSpPr txBox="1"/>
-            <p:nvPr/>
-          </p:nvSpPr>
-          <p:spPr>
-            <a:xfrm>
-              <a:off x="907542" y="2387918"/>
-              <a:ext cx="2093696" cy="264033"/>
-            </a:xfrm>
-            <a:prstGeom prst="rect">
-              <a:avLst/>
-            </a:prstGeom>
-            <a:noFill/>
-            <a:ln>
-              <a:noFill/>
-            </a:ln>
-          </p:spPr>
-          <p:txBody>
-            <a:bodyPr wrap="none" lIns="0" tIns="0" rIns="0" bIns="0" anchor="t" anchorCtr="0">
-              <a:spAutoFit/>
-            </a:bodyPr>
-            <a:lstStyle/>
-            <a:p>
-              <a:pPr algn="l"/>
-              <a:r>
-                <a:rPr lang="zh-CN" sz="1350" b="1" dirty="0">
-                  <a:solidFill>
-                    <a:schemeClr val="accent1"/>
-                  </a:solidFill>
-                  <a:latin typeface="Segoe UI"/>
-                  <a:ea typeface="Microsoft YaHei"/>
-                  <a:cs typeface="Segoe UI"/>
-                </a:rPr>
-                <a:t>1 复用开源的 Codex CLI</a:t>
-              </a:r>
-            </a:p>
-          </p:txBody>
-        </p:sp>
-        <p:sp>
-          <p:nvSpPr>
-            <p:cNvPr id="9" name="TextBox 9"/>
-            <p:cNvSpPr txBox="1"/>
-            <p:nvPr/>
-          </p:nvSpPr>
-          <p:spPr>
-            <a:xfrm>
-              <a:off x="907542" y="2692718"/>
-              <a:ext cx="3999928" cy="511683"/>
-            </a:xfrm>
-            <a:prstGeom prst="rect">
-              <a:avLst/>
-            </a:prstGeom>
-            <a:noFill/>
-            <a:ln>
-              <a:noFill/>
-            </a:ln>
-          </p:spPr>
-          <p:txBody>
-            <a:bodyPr wrap="square" lIns="0" tIns="0" rIns="0" bIns="0" anchor="t" anchorCtr="0"/>
-            <a:lstStyle/>
-            <a:p>
-              <a:pPr algn="l">
-                <a:lnSpc>
-                  <a:spcPts val="1950"/>
-                </a:lnSpc>
-              </a:pPr>
-              <a:r>
-                <a:rPr lang="zh-CN" sz="1350" dirty="0">
-                  <a:solidFill>
-                    <a:schemeClr val="dk1"/>
-                  </a:solidFill>
-                  <a:latin typeface="Segoe UI"/>
-                  <a:ea typeface="Microsoft YaHei"/>
-                  <a:cs typeface="Segoe UI"/>
-                </a:rPr>
-                <a:t>把 Codex CLI 作为 Agent 宿主，9 个角色都是可读的</a:t>
-              </a:r>
-              <a:r>
-                <a:rPr lang="zh-CN" sz="1350" dirty="0">
-                  <a:solidFill>
-                    <a:schemeClr val="dk1"/>
-                  </a:solidFill>
-                  <a:latin typeface="Segoe UI"/>
-                  <a:ea typeface="Microsoft YaHei"/>
-                  <a:cs typeface="Segoe UI"/>
-                </a:rPr>
-                <a:t>Markdown 说明。</a:t>
-              </a:r>
-            </a:p>
-          </p:txBody>
-        </p:sp>
-        <p:sp>
-          <p:nvSpPr>
-            <p:cNvPr id="10" name="Line 10"/>
-            <p:cNvSpPr/>
-            <p:nvPr/>
-          </p:nvSpPr>
-          <p:spPr>
-            <a:xfrm>
-              <a:off x="914400" y="3257550"/>
-              <a:ext cx="4838700" cy="9525"/>
-            </a:xfrm>
-            <a:custGeom>
-              <a:avLst/>
-              <a:gdLst/>
-              <a:ahLst/>
-              <a:cxnLst/>
-              <a:rect l="l" t="t" r="r" b="b"/>
-              <a:pathLst>
-                <a:path w="4838700" h="9525">
-                  <a:moveTo>
-                    <a:pt x="0" y="0"/>
-                  </a:moveTo>
-                  <a:lnTo>
-                    <a:pt x="4838700" y="0"/>
-                  </a:lnTo>
-                </a:path>
-              </a:pathLst>
-            </a:custGeom>
-            <a:noFill/>
-            <a:ln w="9525">
-              <a:solidFill>
-                <a:schemeClr val="accent4"/>
-              </a:solidFill>
-            </a:ln>
-          </p:spPr>
-        </p:sp>
-        <p:sp>
-          <p:nvSpPr>
-            <p:cNvPr id="11" name="TextBox 11"/>
-            <p:cNvSpPr txBox="1"/>
-            <p:nvPr/>
-          </p:nvSpPr>
-          <p:spPr>
-            <a:xfrm>
-              <a:off x="907542" y="3435668"/>
-              <a:ext cx="1888830" cy="264033"/>
-            </a:xfrm>
-            <a:prstGeom prst="rect">
-              <a:avLst/>
-            </a:prstGeom>
-            <a:noFill/>
-            <a:ln>
-              <a:noFill/>
-            </a:ln>
-          </p:spPr>
-          <p:txBody>
-            <a:bodyPr wrap="none" lIns="0" tIns="0" rIns="0" bIns="0" anchor="t" anchorCtr="0">
-              <a:spAutoFit/>
-            </a:bodyPr>
-            <a:lstStyle/>
-            <a:p>
-              <a:pPr algn="l"/>
-              <a:r>
-                <a:rPr lang="zh-CN" sz="1350" b="1" dirty="0">
-                  <a:solidFill>
-                    <a:schemeClr val="accent1"/>
-                  </a:solidFill>
-                  <a:latin typeface="Segoe UI"/>
-                  <a:ea typeface="Microsoft YaHei"/>
-                  <a:cs typeface="Segoe UI"/>
-                </a:rPr>
-                <a:t>2 四个自研 MCP 服务</a:t>
-              </a:r>
-            </a:p>
-          </p:txBody>
-        </p:sp>
-        <p:sp>
-          <p:nvSpPr>
-            <p:cNvPr id="12" name="TextBox 12"/>
-            <p:cNvSpPr txBox="1"/>
-            <p:nvPr/>
-          </p:nvSpPr>
-          <p:spPr>
-            <a:xfrm>
-              <a:off x="907542" y="3740468"/>
-              <a:ext cx="3845623" cy="511683"/>
-            </a:xfrm>
-            <a:prstGeom prst="rect">
-              <a:avLst/>
-            </a:prstGeom>
-            <a:noFill/>
-            <a:ln>
-              <a:noFill/>
-            </a:ln>
-          </p:spPr>
-          <p:txBody>
-            <a:bodyPr wrap="square" lIns="0" tIns="0" rIns="0" bIns="0" anchor="t" anchorCtr="0"/>
-            <a:lstStyle/>
-            <a:p>
-              <a:pPr algn="l">
-                <a:lnSpc>
-                  <a:spcPts val="1950"/>
-                </a:lnSpc>
-              </a:pPr>
-              <a:r>
-                <a:rPr lang="zh-CN" sz="1350" dirty="0">
-                  <a:solidFill>
-                    <a:schemeClr val="dk1"/>
-                  </a:solidFill>
-                  <a:latin typeface="Segoe UI"/>
-                  <a:ea typeface="Microsoft YaHei"/>
-                  <a:cs typeface="Segoe UI"/>
-                </a:rPr>
-                <a:t>文献检索、引用核对、绘图、RECIPE 前驱体预测，</a:t>
-              </a:r>
-              <a:r>
-                <a:rPr lang="zh-CN" sz="1350" dirty="0">
-                  <a:solidFill>
-                    <a:schemeClr val="dk1"/>
-                  </a:solidFill>
-                  <a:latin typeface="Segoe UI"/>
-                  <a:ea typeface="Microsoft YaHei"/>
-                  <a:cs typeface="Segoe UI"/>
-                </a:rPr>
-                <a:t>全部自主设计并开源。</a:t>
-              </a:r>
-            </a:p>
-          </p:txBody>
-        </p:sp>
-        <p:sp>
-          <p:nvSpPr>
-            <p:cNvPr id="13" name="Line 13"/>
-            <p:cNvSpPr/>
-            <p:nvPr/>
-          </p:nvSpPr>
-          <p:spPr>
-            <a:xfrm>
-              <a:off x="914400" y="4305300"/>
-              <a:ext cx="4838700" cy="9525"/>
-            </a:xfrm>
-            <a:custGeom>
-              <a:avLst/>
-              <a:gdLst/>
-              <a:ahLst/>
-              <a:cxnLst/>
-              <a:rect l="l" t="t" r="r" b="b"/>
-              <a:pathLst>
-                <a:path w="4838700" h="9525">
-                  <a:moveTo>
-                    <a:pt x="0" y="0"/>
-                  </a:moveTo>
-                  <a:lnTo>
-                    <a:pt x="4838700" y="0"/>
-                  </a:lnTo>
-                </a:path>
-              </a:pathLst>
-            </a:custGeom>
-            <a:noFill/>
-            <a:ln w="9525">
-              <a:solidFill>
-                <a:schemeClr val="accent4"/>
-              </a:solidFill>
-            </a:ln>
-          </p:spPr>
-        </p:sp>
-        <p:sp>
-          <p:nvSpPr>
-            <p:cNvPr id="14" name="TextBox 14"/>
-            <p:cNvSpPr txBox="1"/>
-            <p:nvPr/>
-          </p:nvSpPr>
-          <p:spPr>
-            <a:xfrm>
-              <a:off x="907542" y="4483418"/>
-              <a:ext cx="2084155" cy="264033"/>
-            </a:xfrm>
-            <a:prstGeom prst="rect">
-              <a:avLst/>
-            </a:prstGeom>
-            <a:noFill/>
-            <a:ln>
-              <a:noFill/>
-            </a:ln>
-          </p:spPr>
-          <p:txBody>
-            <a:bodyPr wrap="none" lIns="0" tIns="0" rIns="0" bIns="0" anchor="t" anchorCtr="0">
-              <a:spAutoFit/>
-            </a:bodyPr>
-            <a:lstStyle/>
-            <a:p>
-              <a:pPr algn="l"/>
-              <a:r>
-                <a:rPr lang="zh-CN" sz="1350" b="1" dirty="0">
-                  <a:solidFill>
-                    <a:schemeClr val="accent1"/>
-                  </a:solidFill>
-                  <a:latin typeface="Segoe UI"/>
-                  <a:ea typeface="Microsoft YaHei"/>
-                  <a:cs typeface="Segoe UI"/>
-                </a:rPr>
-                <a:t>3 一键复现与确定性检查</a:t>
-              </a:r>
-            </a:p>
-          </p:txBody>
-        </p:sp>
-        <p:sp>
-          <p:nvSpPr>
-            <p:cNvPr id="15" name="TextBox 15"/>
-            <p:cNvSpPr txBox="1"/>
-            <p:nvPr/>
-          </p:nvSpPr>
-          <p:spPr>
-            <a:xfrm>
-              <a:off x="907542" y="4788218"/>
-              <a:ext cx="4377118" cy="759333"/>
-            </a:xfrm>
-            <a:prstGeom prst="rect">
-              <a:avLst/>
-            </a:prstGeom>
-            <a:noFill/>
-            <a:ln>
-              <a:noFill/>
-            </a:ln>
-          </p:spPr>
-          <p:txBody>
-            <a:bodyPr wrap="square" lIns="0" tIns="0" rIns="0" bIns="0" anchor="t" anchorCtr="0"/>
-            <a:lstStyle/>
-            <a:p>
-              <a:pPr algn="l">
-                <a:lnSpc>
-                  <a:spcPts val="1950"/>
-                </a:lnSpc>
-              </a:pPr>
-              <a:r>
-                <a:rPr lang="zh-CN" sz="1350" dirty="0">
-                  <a:solidFill>
-                    <a:schemeClr val="dk1"/>
-                  </a:solidFill>
-                  <a:latin typeface="Segoe UI"/>
-                  <a:ea typeface="Microsoft YaHei"/>
-                  <a:cs typeface="Segoe UI"/>
-                </a:rPr>
-                <a:t>uv.lock 冻结安装；smoke 覆盖 4 个 MCP 与 65 项测试；</a:t>
-              </a:r>
-              <a:r>
-                <a:rPr lang="zh-CN" sz="1350" dirty="0">
-                  <a:solidFill>
-                    <a:schemeClr val="dk1"/>
-                  </a:solidFill>
-                  <a:latin typeface="Segoe UI"/>
-                  <a:ea typeface="Microsoft YaHei"/>
-                  <a:cs typeface="Segoe UI"/>
-                </a:rPr>
-                <a:t>reproduce_core 强制检查 PDF、BibTeX、审计、图源、</a:t>
-              </a:r>
-              <a:r>
-                <a:rPr lang="zh-CN" sz="1350" dirty="0">
-                  <a:solidFill>
-                    <a:schemeClr val="dk1"/>
-                  </a:solidFill>
-                  <a:latin typeface="Segoe UI"/>
-                  <a:ea typeface="Microsoft YaHei"/>
-                  <a:cs typeface="Segoe UI"/>
-                </a:rPr>
-                <a:t>ledger 与逐任务 JSONL，并生成复现收据。</a:t>
+                <a:t>才算复现成功。</a:t>
               </a:r>
             </a:p>
           </p:txBody>
@@ -6296,22 +5919,22 @@
         </p:nvGrpSpPr>
         <p:grpSpPr>
           <a:xfrm>
-            <a:off x="6210300" y="2190750"/>
-            <a:ext cx="5295900" cy="3829050"/>
-            <a:chOff x="6210300" y="2190750"/>
-            <a:chExt cx="5295900" cy="3829050"/>
+            <a:off x="685800" y="2171700"/>
+            <a:ext cx="5816155" cy="3429000"/>
+            <a:chOff x="685800" y="2171700"/>
+            <a:chExt cx="5816155" cy="3429000"/>
           </a:xfrm>
         </p:grpSpPr>
         <p:sp>
           <p:nvSpPr>
-            <p:cNvPr id="17" name="Rectangle 17"/>
+            <p:cNvPr id="7" name="Rectangle 7"/>
             <p:cNvSpPr/>
             <p:nvPr/>
           </p:nvSpPr>
           <p:spPr>
             <a:xfrm>
-              <a:off x="6210300" y="2190750"/>
-              <a:ext cx="5295900" cy="3829050"/>
+              <a:off x="685800" y="2171700"/>
+              <a:ext cx="5295900" cy="1638300"/>
             </a:xfrm>
             <a:prstGeom prst="rect">
               <a:avLst/>
@@ -6324,108 +5947,419 @@
             </a:ln>
           </p:spPr>
         </p:sp>
-        <p:sp>
-          <p:nvSpPr>
-            <p:cNvPr id="18" name="Freeform 18"/>
-            <p:cNvSpPr/>
-            <p:nvPr/>
-          </p:nvSpPr>
-          <p:spPr>
-            <a:xfrm>
-              <a:off x="6472238" y="2450465"/>
-              <a:ext cx="188913" cy="202248"/>
-            </a:xfrm>
-            <a:custGeom>
-              <a:avLst/>
-              <a:gdLst/>
-              <a:ahLst/>
-              <a:cxnLst/>
-              <a:rect l="l" t="t" r="r" b="b"/>
-              <a:pathLst>
-                <a:path w="188913" h="202248">
-                  <a:moveTo>
-                    <a:pt x="66675" y="180023"/>
-                  </a:moveTo>
-                  <a:cubicBezTo>
-                    <a:pt x="18891" y="195581"/>
-                    <a:pt x="18891" y="152242"/>
-                    <a:pt x="0" y="146685"/>
-                  </a:cubicBezTo>
-                  <a:moveTo>
-                    <a:pt x="133350" y="202248"/>
-                  </a:moveTo>
-                  <a:lnTo>
-                    <a:pt x="133350" y="163354"/>
-                  </a:lnTo>
-                  <a:cubicBezTo>
-                    <a:pt x="133350" y="152242"/>
-                    <a:pt x="134462" y="147797"/>
-                    <a:pt x="127794" y="141129"/>
-                  </a:cubicBezTo>
-                  <a:cubicBezTo>
-                    <a:pt x="158909" y="137795"/>
-                    <a:pt x="188913" y="125572"/>
-                    <a:pt x="188913" y="74454"/>
-                  </a:cubicBezTo>
-                  <a:cubicBezTo>
-                    <a:pt x="188900" y="61174"/>
-                    <a:pt x="183718" y="48421"/>
-                    <a:pt x="174467" y="38894"/>
-                  </a:cubicBezTo>
-                  <a:cubicBezTo>
-                    <a:pt x="178806" y="27359"/>
-                    <a:pt x="178406" y="14576"/>
-                    <a:pt x="173355" y="3334"/>
-                  </a:cubicBezTo>
-                  <a:cubicBezTo>
-                    <a:pt x="173355" y="3334"/>
-                    <a:pt x="161132" y="0"/>
-                    <a:pt x="134462" y="17780"/>
-                  </a:cubicBezTo>
-                  <a:cubicBezTo>
-                    <a:pt x="111873" y="11897"/>
-                    <a:pt x="88153" y="11897"/>
-                    <a:pt x="65564" y="17780"/>
-                  </a:cubicBezTo>
-                  <a:cubicBezTo>
-                    <a:pt x="38894" y="0"/>
-                    <a:pt x="26670" y="3334"/>
-                    <a:pt x="26670" y="3334"/>
-                  </a:cubicBezTo>
-                  <a:cubicBezTo>
-                    <a:pt x="21619" y="14576"/>
-                    <a:pt x="21220" y="27359"/>
-                    <a:pt x="25559" y="38894"/>
-                  </a:cubicBezTo>
-                  <a:cubicBezTo>
-                    <a:pt x="16307" y="48421"/>
-                    <a:pt x="11126" y="61174"/>
-                    <a:pt x="11113" y="74454"/>
-                  </a:cubicBezTo>
-                  <a:cubicBezTo>
-                    <a:pt x="11113" y="125572"/>
-                    <a:pt x="41116" y="137795"/>
-                    <a:pt x="72231" y="141129"/>
-                  </a:cubicBezTo>
-                  <a:cubicBezTo>
-                    <a:pt x="65564" y="147797"/>
-                    <a:pt x="65564" y="154464"/>
-                    <a:pt x="66675" y="163354"/>
-                  </a:cubicBezTo>
-                  <a:lnTo>
-                    <a:pt x="66675" y="202248"/>
-                  </a:lnTo>
-                </a:path>
-              </a:pathLst>
-            </a:custGeom>
-            <a:noFill/>
-            <a:ln w="19050">
-              <a:solidFill>
-                <a:schemeClr val="accent1"/>
-              </a:solidFill>
-            </a:ln>
-          </p:spPr>
-        </p:sp>
+        <p:grpSp>
+          <p:nvGrpSpPr>
+            <p:cNvPr id="18" name="Group 18"/>
+            <p:cNvGrpSpPr/>
+            <p:nvPr/>
+          </p:nvGrpSpPr>
+          <p:grpSpPr>
+            <a:xfrm>
+              <a:off x="947738" y="2414588"/>
+              <a:ext cx="200025" cy="200025"/>
+              <a:chOff x="947738" y="2414588"/>
+              <a:chExt cx="200025" cy="200025"/>
+            </a:xfrm>
+          </p:grpSpPr>
+          <p:sp>
+            <p:nvSpPr>
+              <p:cNvPr id="8" name="Freeform 8"/>
+              <p:cNvSpPr/>
+              <p:nvPr/>
+            </p:nvSpPr>
+            <p:spPr>
+              <a:xfrm>
+                <a:off x="969963" y="2436813"/>
+                <a:ext cx="155575" cy="155575"/>
+              </a:xfrm>
+              <a:custGeom>
+                <a:avLst/>
+                <a:gdLst/>
+                <a:ahLst/>
+                <a:cxnLst/>
+                <a:rect l="l" t="t" r="r" b="b"/>
+                <a:pathLst>
+                  <a:path w="155575" h="155575">
+                    <a:moveTo>
+                      <a:pt x="0" y="11113"/>
+                    </a:moveTo>
+                    <a:cubicBezTo>
+                      <a:pt x="0" y="4975"/>
+                      <a:pt x="4975" y="0"/>
+                      <a:pt x="11113" y="0"/>
+                    </a:cubicBezTo>
+                    <a:lnTo>
+                      <a:pt x="144463" y="0"/>
+                    </a:lnTo>
+                    <a:cubicBezTo>
+                      <a:pt x="150600" y="0"/>
+                      <a:pt x="155575" y="4975"/>
+                      <a:pt x="155575" y="11113"/>
+                    </a:cubicBezTo>
+                    <a:lnTo>
+                      <a:pt x="155575" y="144463"/>
+                    </a:lnTo>
+                    <a:cubicBezTo>
+                      <a:pt x="155575" y="150600"/>
+                      <a:pt x="150600" y="155575"/>
+                      <a:pt x="144463" y="155575"/>
+                    </a:cubicBezTo>
+                    <a:lnTo>
+                      <a:pt x="11113" y="155575"/>
+                    </a:lnTo>
+                    <a:cubicBezTo>
+                      <a:pt x="4975" y="155575"/>
+                      <a:pt x="0" y="150600"/>
+                      <a:pt x="0" y="144463"/>
+                    </a:cubicBezTo>
+                    <a:lnTo>
+                      <a:pt x="0" y="11113"/>
+                    </a:lnTo>
+                  </a:path>
+                </a:pathLst>
+              </a:custGeom>
+              <a:noFill/>
+              <a:ln w="19050">
+                <a:solidFill>
+                  <a:schemeClr val="accent1"/>
+                </a:solidFill>
+              </a:ln>
+            </p:spPr>
+          </p:sp>
+          <p:sp>
+            <p:nvSpPr>
+              <p:cNvPr id="9" name="Freeform 9"/>
+              <p:cNvSpPr/>
+              <p:nvPr/>
+            </p:nvSpPr>
+            <p:spPr>
+              <a:xfrm>
+                <a:off x="1014413" y="2481263"/>
+                <a:ext cx="66675" cy="66675"/>
+              </a:xfrm>
+              <a:custGeom>
+                <a:avLst/>
+                <a:gdLst/>
+                <a:ahLst/>
+                <a:cxnLst/>
+                <a:rect l="l" t="t" r="r" b="b"/>
+                <a:pathLst>
+                  <a:path w="66675" h="66675">
+                    <a:moveTo>
+                      <a:pt x="0" y="0"/>
+                    </a:moveTo>
+                    <a:lnTo>
+                      <a:pt x="66675" y="0"/>
+                    </a:lnTo>
+                    <a:lnTo>
+                      <a:pt x="66675" y="66675"/>
+                    </a:lnTo>
+                    <a:lnTo>
+                      <a:pt x="0" y="66675"/>
+                    </a:lnTo>
+                    <a:lnTo>
+                      <a:pt x="0" y="0"/>
+                    </a:lnTo>
+                  </a:path>
+                </a:pathLst>
+              </a:custGeom>
+              <a:noFill/>
+              <a:ln w="19050">
+                <a:solidFill>
+                  <a:schemeClr val="accent1"/>
+                </a:solidFill>
+              </a:ln>
+            </p:spPr>
+          </p:sp>
+          <p:sp>
+            <p:nvSpPr>
+              <p:cNvPr id="10" name="Freeform 10"/>
+              <p:cNvSpPr/>
+              <p:nvPr/>
+            </p:nvSpPr>
+            <p:spPr>
+              <a:xfrm>
+                <a:off x="947738" y="2492375"/>
+                <a:ext cx="22225" cy="9525"/>
+              </a:xfrm>
+              <a:custGeom>
+                <a:avLst/>
+                <a:gdLst/>
+                <a:ahLst/>
+                <a:cxnLst/>
+                <a:rect l="l" t="t" r="r" b="b"/>
+                <a:pathLst>
+                  <a:path w="22225" h="9525">
+                    <a:moveTo>
+                      <a:pt x="0" y="0"/>
+                    </a:moveTo>
+                    <a:lnTo>
+                      <a:pt x="22225" y="0"/>
+                    </a:lnTo>
+                  </a:path>
+                </a:pathLst>
+              </a:custGeom>
+              <a:noFill/>
+              <a:ln w="19050">
+                <a:solidFill>
+                  <a:schemeClr val="accent1"/>
+                </a:solidFill>
+              </a:ln>
+            </p:spPr>
+          </p:sp>
+          <p:sp>
+            <p:nvSpPr>
+              <p:cNvPr id="11" name="Freeform 11"/>
+              <p:cNvSpPr/>
+              <p:nvPr/>
+            </p:nvSpPr>
+            <p:spPr>
+              <a:xfrm>
+                <a:off x="947738" y="2536825"/>
+                <a:ext cx="22225" cy="9525"/>
+              </a:xfrm>
+              <a:custGeom>
+                <a:avLst/>
+                <a:gdLst/>
+                <a:ahLst/>
+                <a:cxnLst/>
+                <a:rect l="l" t="t" r="r" b="b"/>
+                <a:pathLst>
+                  <a:path w="22225" h="9525">
+                    <a:moveTo>
+                      <a:pt x="0" y="0"/>
+                    </a:moveTo>
+                    <a:lnTo>
+                      <a:pt x="22225" y="0"/>
+                    </a:lnTo>
+                  </a:path>
+                </a:pathLst>
+              </a:custGeom>
+              <a:noFill/>
+              <a:ln w="19050">
+                <a:solidFill>
+                  <a:schemeClr val="accent1"/>
+                </a:solidFill>
+              </a:ln>
+            </p:spPr>
+          </p:sp>
+          <p:sp>
+            <p:nvSpPr>
+              <p:cNvPr id="12" name="Freeform 12"/>
+              <p:cNvSpPr/>
+              <p:nvPr/>
+            </p:nvSpPr>
+            <p:spPr>
+              <a:xfrm>
+                <a:off x="1025525" y="2414588"/>
+                <a:ext cx="9525" cy="22225"/>
+              </a:xfrm>
+              <a:custGeom>
+                <a:avLst/>
+                <a:gdLst/>
+                <a:ahLst/>
+                <a:cxnLst/>
+                <a:rect l="l" t="t" r="r" b="b"/>
+                <a:pathLst>
+                  <a:path w="9525" h="22225">
+                    <a:moveTo>
+                      <a:pt x="0" y="0"/>
+                    </a:moveTo>
+                    <a:lnTo>
+                      <a:pt x="0" y="22225"/>
+                    </a:lnTo>
+                  </a:path>
+                </a:pathLst>
+              </a:custGeom>
+              <a:noFill/>
+              <a:ln w="19050">
+                <a:solidFill>
+                  <a:schemeClr val="accent1"/>
+                </a:solidFill>
+              </a:ln>
+            </p:spPr>
+          </p:sp>
+          <p:sp>
+            <p:nvSpPr>
+              <p:cNvPr id="13" name="Freeform 13"/>
+              <p:cNvSpPr/>
+              <p:nvPr/>
+            </p:nvSpPr>
+            <p:spPr>
+              <a:xfrm>
+                <a:off x="1069975" y="2414588"/>
+                <a:ext cx="9525" cy="22225"/>
+              </a:xfrm>
+              <a:custGeom>
+                <a:avLst/>
+                <a:gdLst/>
+                <a:ahLst/>
+                <a:cxnLst/>
+                <a:rect l="l" t="t" r="r" b="b"/>
+                <a:pathLst>
+                  <a:path w="9525" h="22225">
+                    <a:moveTo>
+                      <a:pt x="0" y="0"/>
+                    </a:moveTo>
+                    <a:lnTo>
+                      <a:pt x="0" y="22225"/>
+                    </a:lnTo>
+                  </a:path>
+                </a:pathLst>
+              </a:custGeom>
+              <a:noFill/>
+              <a:ln w="19050">
+                <a:solidFill>
+                  <a:schemeClr val="accent1"/>
+                </a:solidFill>
+              </a:ln>
+            </p:spPr>
+          </p:sp>
+          <p:sp>
+            <p:nvSpPr>
+              <p:cNvPr id="14" name="Freeform 14"/>
+              <p:cNvSpPr/>
+              <p:nvPr/>
+            </p:nvSpPr>
+            <p:spPr>
+              <a:xfrm>
+                <a:off x="1125538" y="2492375"/>
+                <a:ext cx="22225" cy="9525"/>
+              </a:xfrm>
+              <a:custGeom>
+                <a:avLst/>
+                <a:gdLst/>
+                <a:ahLst/>
+                <a:cxnLst/>
+                <a:rect l="l" t="t" r="r" b="b"/>
+                <a:pathLst>
+                  <a:path w="22225" h="9525">
+                    <a:moveTo>
+                      <a:pt x="22225" y="0"/>
+                    </a:moveTo>
+                    <a:lnTo>
+                      <a:pt x="0" y="0"/>
+                    </a:lnTo>
+                  </a:path>
+                </a:pathLst>
+              </a:custGeom>
+              <a:noFill/>
+              <a:ln w="19050">
+                <a:solidFill>
+                  <a:schemeClr val="accent1"/>
+                </a:solidFill>
+              </a:ln>
+            </p:spPr>
+          </p:sp>
+          <p:sp>
+            <p:nvSpPr>
+              <p:cNvPr id="15" name="Freeform 15"/>
+              <p:cNvSpPr/>
+              <p:nvPr/>
+            </p:nvSpPr>
+            <p:spPr>
+              <a:xfrm>
+                <a:off x="1125538" y="2536825"/>
+                <a:ext cx="22225" cy="9525"/>
+              </a:xfrm>
+              <a:custGeom>
+                <a:avLst/>
+                <a:gdLst/>
+                <a:ahLst/>
+                <a:cxnLst/>
+                <a:rect l="l" t="t" r="r" b="b"/>
+                <a:pathLst>
+                  <a:path w="22225" h="9525">
+                    <a:moveTo>
+                      <a:pt x="22225" y="0"/>
+                    </a:moveTo>
+                    <a:lnTo>
+                      <a:pt x="0" y="0"/>
+                    </a:lnTo>
+                  </a:path>
+                </a:pathLst>
+              </a:custGeom>
+              <a:noFill/>
+              <a:ln w="19050">
+                <a:solidFill>
+                  <a:schemeClr val="accent1"/>
+                </a:solidFill>
+              </a:ln>
+            </p:spPr>
+          </p:sp>
+          <p:sp>
+            <p:nvSpPr>
+              <p:cNvPr id="16" name="Freeform 16"/>
+              <p:cNvSpPr/>
+              <p:nvPr/>
+            </p:nvSpPr>
+            <p:spPr>
+              <a:xfrm>
+                <a:off x="1069975" y="2592388"/>
+                <a:ext cx="9525" cy="22225"/>
+              </a:xfrm>
+              <a:custGeom>
+                <a:avLst/>
+                <a:gdLst/>
+                <a:ahLst/>
+                <a:cxnLst/>
+                <a:rect l="l" t="t" r="r" b="b"/>
+                <a:pathLst>
+                  <a:path w="9525" h="22225">
+                    <a:moveTo>
+                      <a:pt x="0" y="22225"/>
+                    </a:moveTo>
+                    <a:lnTo>
+                      <a:pt x="0" y="0"/>
+                    </a:lnTo>
+                  </a:path>
+                </a:pathLst>
+              </a:custGeom>
+              <a:noFill/>
+              <a:ln w="19050">
+                <a:solidFill>
+                  <a:schemeClr val="accent1"/>
+                </a:solidFill>
+              </a:ln>
+            </p:spPr>
+          </p:sp>
+          <p:sp>
+            <p:nvSpPr>
+              <p:cNvPr id="17" name="Freeform 17"/>
+              <p:cNvSpPr/>
+              <p:nvPr/>
+            </p:nvSpPr>
+            <p:spPr>
+              <a:xfrm>
+                <a:off x="1025525" y="2592388"/>
+                <a:ext cx="9525" cy="22225"/>
+              </a:xfrm>
+              <a:custGeom>
+                <a:avLst/>
+                <a:gdLst/>
+                <a:ahLst/>
+                <a:cxnLst/>
+                <a:rect l="l" t="t" r="r" b="b"/>
+                <a:pathLst>
+                  <a:path w="9525" h="22225">
+                    <a:moveTo>
+                      <a:pt x="0" y="22225"/>
+                    </a:moveTo>
+                    <a:lnTo>
+                      <a:pt x="0" y="0"/>
+                    </a:lnTo>
+                  </a:path>
+                </a:pathLst>
+              </a:custGeom>
+              <a:noFill/>
+              <a:ln w="19050">
+                <a:solidFill>
+                  <a:schemeClr val="accent1"/>
+                </a:solidFill>
+              </a:ln>
+            </p:spPr>
+          </p:sp>
+        </p:grpSp>
         <p:sp>
           <p:nvSpPr>
             <p:cNvPr id="19" name="TextBox 19"/>
@@ -6434,8 +6368,8 @@
           </p:nvSpPr>
           <p:spPr>
             <a:xfrm>
-              <a:off x="6793992" y="2483168"/>
-              <a:ext cx="2274979" cy="264033"/>
+              <a:off x="1267206" y="2396490"/>
+              <a:ext cx="3131717" cy="352044"/>
             </a:xfrm>
             <a:prstGeom prst="rect">
               <a:avLst/>
@@ -6453,7 +6387,7 @@
             <a:p>
               <a:pPr algn="l"/>
               <a:r>
-                <a:rPr lang="zh-CN" sz="1350" b="1" dirty="0">
+                <a:rPr lang="zh-CN" sz="1800" b="1" dirty="0">
                   <a:solidFill>
                     <a:schemeClr val="accent1"/>
                   </a:solidFill>
@@ -6461,7 +6395,7 @@
                   <a:ea typeface="Microsoft YaHei"/>
                   <a:cs typeface="Segoe UI"/>
                 </a:rPr>
-                <a:t>4 开源、可编辑与安全导出</a:t>
+                <a:t>1 开源的 Codex CLI 做宿主</a:t>
               </a:r>
             </a:p>
           </p:txBody>
@@ -6474,8 +6408,8 @@
           </p:nvSpPr>
           <p:spPr>
             <a:xfrm>
-              <a:off x="6432042" y="2787968"/>
-              <a:ext cx="4171378" cy="759333"/>
+              <a:off x="907542" y="2807018"/>
+              <a:ext cx="4574286" cy="530733"/>
             </a:xfrm>
             <a:prstGeom prst="rect">
               <a:avLst/>
@@ -6491,7 +6425,7 @@
             <a:p>
               <a:pPr algn="l">
                 <a:lnSpc>
-                  <a:spcPts val="1950"/>
+                  <a:spcPts val="2100"/>
                 </a:lnSpc>
               </a:pPr>
               <a:r>
@@ -6503,7 +6437,7 @@
                   <a:ea typeface="Microsoft YaHei"/>
                   <a:cs typeface="Segoe UI"/>
                 </a:rPr>
-                <a:t>一份图源同时生成论文图与 draw.io 可编辑图；</a:t>
+                <a:t>9 个 Agent 角色都是纯 Markdown 说明，任何宿主都能读；</a:t>
               </a:r>
               <a:r>
                 <a:rPr lang="zh-CN" sz="1350" dirty="0">
@@ -6514,55 +6448,30 @@
                   <a:ea typeface="Microsoft YaHei"/>
                   <a:cs typeface="Segoe UI"/>
                 </a:rPr>
-                <a:t>导出器同时扫描普通文本与压缩轨迹，规范化 JSONL，</a:t>
-              </a:r>
-              <a:r>
-                <a:rPr lang="zh-CN" sz="1350" dirty="0">
-                  <a:solidFill>
-                    <a:schemeClr val="dk1"/>
-                  </a:solidFill>
-                  <a:latin typeface="Segoe UI"/>
-                  <a:ea typeface="Microsoft YaHei"/>
-                  <a:cs typeface="Segoe UI"/>
-                </a:rPr>
-                <a:t>发现凭证、私有路径或非法结构即拒绝打包。</a:t>
-              </a:r>
-            </a:p>
-          </p:txBody>
-        </p:sp>
-        <p:sp>
-          <p:nvSpPr>
-            <p:cNvPr id="21" name="Line 21"/>
+                <a:t>模型 gpt-5.6-sol、推理强度 xhigh，写进配置随包提交。</a:t>
+              </a:r>
+            </a:p>
+          </p:txBody>
+        </p:sp>
+        <p:sp>
+          <p:nvSpPr>
+            <p:cNvPr id="21" name="Rectangle 21"/>
             <p:cNvSpPr/>
             <p:nvPr/>
           </p:nvSpPr>
           <p:spPr>
             <a:xfrm>
-              <a:off x="6438900" y="3905250"/>
-              <a:ext cx="4838700" cy="9525"/>
-            </a:xfrm>
-            <a:custGeom>
-              <a:avLst/>
-              <a:gdLst/>
-              <a:ahLst/>
-              <a:cxnLst/>
-              <a:rect l="l" t="t" r="r" b="b"/>
-              <a:pathLst>
-                <a:path w="4838700" h="9525">
-                  <a:moveTo>
-                    <a:pt x="0" y="0"/>
-                  </a:moveTo>
-                  <a:lnTo>
-                    <a:pt x="4838700" y="0"/>
-                  </a:lnTo>
-                </a:path>
-              </a:pathLst>
-            </a:custGeom>
-            <a:noFill/>
-            <a:ln w="9525">
-              <a:solidFill>
-                <a:schemeClr val="accent4"/>
-              </a:solidFill>
+              <a:off x="685800" y="3962400"/>
+              <a:ext cx="5295900" cy="1638300"/>
+            </a:xfrm>
+            <a:prstGeom prst="rect">
+              <a:avLst/>
+            </a:prstGeom>
+            <a:solidFill>
+              <a:schemeClr val="lt2"/>
+            </a:solidFill>
+            <a:ln>
+              <a:noFill/>
             </a:ln>
           </p:spPr>
         </p:sp>
@@ -6574,10 +6483,10 @@
           </p:nvGrpSpPr>
           <p:grpSpPr>
             <a:xfrm>
-              <a:off x="6460179" y="4220646"/>
-              <a:ext cx="224134" cy="192560"/>
-              <a:chOff x="6460179" y="4220646"/>
-              <a:chExt cx="224134" cy="192560"/>
+              <a:off x="958850" y="4205288"/>
+              <a:ext cx="177801" cy="200025"/>
+              <a:chOff x="958850" y="4205288"/>
+              <a:chExt cx="177801" cy="200025"/>
             </a:xfrm>
           </p:grpSpPr>
           <p:sp>
@@ -6588,7 +6497,1007 @@
             </p:nvSpPr>
             <p:spPr>
               <a:xfrm>
-                <a:off x="6572250" y="4291013"/>
+                <a:off x="958850" y="4205288"/>
+                <a:ext cx="177801" cy="66675"/>
+              </a:xfrm>
+              <a:custGeom>
+                <a:avLst/>
+                <a:gdLst/>
+                <a:ahLst/>
+                <a:cxnLst/>
+                <a:rect l="l" t="t" r="r" b="b"/>
+                <a:pathLst>
+                  <a:path w="177801" h="66675">
+                    <a:moveTo>
+                      <a:pt x="0" y="33338"/>
+                    </a:moveTo>
+                    <a:cubicBezTo>
+                      <a:pt x="0" y="51749"/>
+                      <a:pt x="39802" y="66675"/>
+                      <a:pt x="88900" y="66675"/>
+                    </a:cubicBezTo>
+                    <a:cubicBezTo>
+                      <a:pt x="137999" y="66675"/>
+                      <a:pt x="177801" y="51749"/>
+                      <a:pt x="177801" y="33338"/>
+                    </a:cubicBezTo>
+                    <a:cubicBezTo>
+                      <a:pt x="177801" y="14926"/>
+                      <a:pt x="137999" y="0"/>
+                      <a:pt x="88900" y="0"/>
+                    </a:cubicBezTo>
+                    <a:cubicBezTo>
+                      <a:pt x="39802" y="0"/>
+                      <a:pt x="0" y="14926"/>
+                      <a:pt x="0" y="33338"/>
+                    </a:cubicBezTo>
+                  </a:path>
+                </a:pathLst>
+              </a:custGeom>
+              <a:noFill/>
+              <a:ln w="19050">
+                <a:solidFill>
+                  <a:schemeClr val="accent1"/>
+                </a:solidFill>
+              </a:ln>
+            </p:spPr>
+          </p:sp>
+          <p:sp>
+            <p:nvSpPr>
+              <p:cNvPr id="23" name="Freeform 23"/>
+              <p:cNvSpPr/>
+              <p:nvPr/>
+            </p:nvSpPr>
+            <p:spPr>
+              <a:xfrm>
+                <a:off x="958850" y="4238625"/>
+                <a:ext cx="177801" cy="100013"/>
+              </a:xfrm>
+              <a:custGeom>
+                <a:avLst/>
+                <a:gdLst/>
+                <a:ahLst/>
+                <a:cxnLst/>
+                <a:rect l="l" t="t" r="r" b="b"/>
+                <a:pathLst>
+                  <a:path w="177801" h="100013">
+                    <a:moveTo>
+                      <a:pt x="0" y="0"/>
+                    </a:moveTo>
+                    <a:lnTo>
+                      <a:pt x="0" y="66675"/>
+                    </a:lnTo>
+                    <a:cubicBezTo>
+                      <a:pt x="0" y="85087"/>
+                      <a:pt x="39802" y="100013"/>
+                      <a:pt x="88900" y="100013"/>
+                    </a:cubicBezTo>
+                    <a:cubicBezTo>
+                      <a:pt x="137999" y="100013"/>
+                      <a:pt x="177801" y="85087"/>
+                      <a:pt x="177801" y="66675"/>
+                    </a:cubicBezTo>
+                    <a:lnTo>
+                      <a:pt x="177801" y="0"/>
+                    </a:lnTo>
+                  </a:path>
+                </a:pathLst>
+              </a:custGeom>
+              <a:noFill/>
+              <a:ln w="19050">
+                <a:solidFill>
+                  <a:schemeClr val="accent1"/>
+                </a:solidFill>
+              </a:ln>
+            </p:spPr>
+          </p:sp>
+          <p:sp>
+            <p:nvSpPr>
+              <p:cNvPr id="24" name="Freeform 24"/>
+              <p:cNvSpPr/>
+              <p:nvPr/>
+            </p:nvSpPr>
+            <p:spPr>
+              <a:xfrm>
+                <a:off x="958850" y="4305300"/>
+                <a:ext cx="177801" cy="100013"/>
+              </a:xfrm>
+              <a:custGeom>
+                <a:avLst/>
+                <a:gdLst/>
+                <a:ahLst/>
+                <a:cxnLst/>
+                <a:rect l="l" t="t" r="r" b="b"/>
+                <a:pathLst>
+                  <a:path w="177801" h="100013">
+                    <a:moveTo>
+                      <a:pt x="0" y="0"/>
+                    </a:moveTo>
+                    <a:lnTo>
+                      <a:pt x="0" y="66675"/>
+                    </a:lnTo>
+                    <a:cubicBezTo>
+                      <a:pt x="0" y="85087"/>
+                      <a:pt x="39802" y="100013"/>
+                      <a:pt x="88900" y="100013"/>
+                    </a:cubicBezTo>
+                    <a:cubicBezTo>
+                      <a:pt x="137999" y="100013"/>
+                      <a:pt x="177801" y="85087"/>
+                      <a:pt x="177801" y="66675"/>
+                    </a:cubicBezTo>
+                    <a:lnTo>
+                      <a:pt x="177801" y="0"/>
+                    </a:lnTo>
+                  </a:path>
+                </a:pathLst>
+              </a:custGeom>
+              <a:noFill/>
+              <a:ln w="19050">
+                <a:solidFill>
+                  <a:schemeClr val="accent1"/>
+                </a:solidFill>
+              </a:ln>
+            </p:spPr>
+          </p:sp>
+        </p:grpSp>
+        <p:sp>
+          <p:nvSpPr>
+            <p:cNvPr id="26" name="TextBox 26"/>
+            <p:cNvSpPr txBox="1"/>
+            <p:nvPr/>
+          </p:nvSpPr>
+          <p:spPr>
+            <a:xfrm>
+              <a:off x="1267206" y="4187190"/>
+              <a:ext cx="2270009" cy="352044"/>
+            </a:xfrm>
+            <a:prstGeom prst="rect">
+              <a:avLst/>
+            </a:prstGeom>
+            <a:noFill/>
+            <a:ln>
+              <a:noFill/>
+            </a:ln>
+          </p:spPr>
+          <p:txBody>
+            <a:bodyPr wrap="none" lIns="0" tIns="0" rIns="0" bIns="0" anchor="t" anchorCtr="0">
+              <a:spAutoFit/>
+            </a:bodyPr>
+            <a:lstStyle/>
+            <a:p>
+              <a:pPr algn="l"/>
+              <a:r>
+                <a:rPr lang="zh-CN" sz="1800" b="1" dirty="0">
+                  <a:solidFill>
+                    <a:schemeClr val="accent1"/>
+                  </a:solidFill>
+                  <a:latin typeface="Segoe UI"/>
+                  <a:ea typeface="Microsoft YaHei"/>
+                  <a:cs typeface="Segoe UI"/>
+                </a:rPr>
+                <a:t>3 知识库与数据边界</a:t>
+              </a:r>
+            </a:p>
+          </p:txBody>
+        </p:sp>
+        <p:sp>
+          <p:nvSpPr>
+            <p:cNvPr id="27" name="TextBox 27"/>
+            <p:cNvSpPr txBox="1"/>
+            <p:nvPr/>
+          </p:nvSpPr>
+          <p:spPr>
+            <a:xfrm>
+              <a:off x="907542" y="4597718"/>
+              <a:ext cx="5594413" cy="530733"/>
+            </a:xfrm>
+            <a:prstGeom prst="rect">
+              <a:avLst/>
+            </a:prstGeom>
+            <a:noFill/>
+            <a:ln>
+              <a:noFill/>
+            </a:ln>
+          </p:spPr>
+          <p:txBody>
+            <a:bodyPr wrap="square" lIns="0" tIns="0" rIns="0" bIns="0" anchor="t" anchorCtr="0"/>
+            <a:lstStyle/>
+            <a:p>
+              <a:pPr algn="l">
+                <a:lnSpc>
+                  <a:spcPts val="2100"/>
+                </a:lnSpc>
+              </a:pPr>
+              <a:r>
+                <a:rPr lang="zh-CN" sz="1350" dirty="0">
+                  <a:solidFill>
+                    <a:schemeClr val="dk1"/>
+                  </a:solidFill>
+                  <a:latin typeface="Segoe UI"/>
+                  <a:ea typeface="Microsoft YaHei"/>
+                  <a:cs typeface="Segoe UI"/>
+                </a:rPr>
+                <a:t>被引 51 篇中 21 篇全文进入公开知识库，其余 30 篇给 DOI；</a:t>
+              </a:r>
+              <a:r>
+                <a:rPr lang="zh-CN" sz="1350" dirty="0">
+                  <a:solidFill>
+                    <a:schemeClr val="dk1"/>
+                  </a:solidFill>
+                  <a:latin typeface="Segoe UI"/>
+                  <a:ea typeface="Microsoft YaHei"/>
+                  <a:cs typeface="Segoe UI"/>
+                </a:rPr>
+                <a:t>在线检索 arXiv / OpenAlex / Crossref / Semantic Scholar 不受影响。</a:t>
+              </a:r>
+            </a:p>
+          </p:txBody>
+        </p:sp>
+      </p:grpSp>
+      <p:grpSp>
+        <p:nvGrpSpPr>
+          <p:cNvPr id="53" name="Group 53"/>
+          <p:cNvGrpSpPr/>
+          <p:nvPr/>
+        </p:nvGrpSpPr>
+        <p:grpSpPr>
+          <a:xfrm>
+            <a:off x="685800" y="2171700"/>
+            <a:ext cx="10820400" cy="4175951"/>
+            <a:chOff x="685800" y="2171700"/>
+            <a:chExt cx="10820400" cy="4175951"/>
+          </a:xfrm>
+        </p:grpSpPr>
+        <p:sp>
+          <p:nvSpPr>
+            <p:cNvPr id="29" name="Rectangle 29"/>
+            <p:cNvSpPr/>
+            <p:nvPr/>
+          </p:nvSpPr>
+          <p:spPr>
+            <a:xfrm>
+              <a:off x="6210300" y="2171700"/>
+              <a:ext cx="5295900" cy="1638300"/>
+            </a:xfrm>
+            <a:prstGeom prst="rect">
+              <a:avLst/>
+            </a:prstGeom>
+            <a:solidFill>
+              <a:schemeClr val="lt2"/>
+            </a:solidFill>
+            <a:ln>
+              <a:noFill/>
+            </a:ln>
+          </p:spPr>
+        </p:sp>
+        <p:grpSp>
+          <p:nvGrpSpPr>
+            <p:cNvPr id="38" name="Group 38"/>
+            <p:cNvGrpSpPr/>
+            <p:nvPr/>
+          </p:nvGrpSpPr>
+          <p:grpSpPr>
+            <a:xfrm>
+              <a:off x="6472238" y="2414588"/>
+              <a:ext cx="200025" cy="211138"/>
+              <a:chOff x="6472238" y="2414588"/>
+              <a:chExt cx="200025" cy="211138"/>
+            </a:xfrm>
+          </p:grpSpPr>
+          <p:sp>
+            <p:nvSpPr>
+              <p:cNvPr id="30" name="Freeform 30"/>
+              <p:cNvSpPr/>
+              <p:nvPr/>
+            </p:nvSpPr>
+            <p:spPr>
+              <a:xfrm>
+                <a:off x="6505575" y="2414588"/>
+                <a:ext cx="133350" cy="133350"/>
+              </a:xfrm>
+              <a:custGeom>
+                <a:avLst/>
+                <a:gdLst/>
+                <a:ahLst/>
+                <a:cxnLst/>
+                <a:rect l="l" t="t" r="r" b="b"/>
+                <a:pathLst>
+                  <a:path w="133350" h="133350">
+                    <a:moveTo>
+                      <a:pt x="0" y="66675"/>
+                    </a:moveTo>
+                    <a:cubicBezTo>
+                      <a:pt x="0" y="103499"/>
+                      <a:pt x="29851" y="133350"/>
+                      <a:pt x="66675" y="133350"/>
+                    </a:cubicBezTo>
+                    <a:cubicBezTo>
+                      <a:pt x="103499" y="133350"/>
+                      <a:pt x="133350" y="103499"/>
+                      <a:pt x="133350" y="66675"/>
+                    </a:cubicBezTo>
+                    <a:cubicBezTo>
+                      <a:pt x="133350" y="29851"/>
+                      <a:pt x="103499" y="0"/>
+                      <a:pt x="66675" y="0"/>
+                    </a:cubicBezTo>
+                    <a:cubicBezTo>
+                      <a:pt x="29851" y="0"/>
+                      <a:pt x="0" y="29851"/>
+                      <a:pt x="0" y="66675"/>
+                    </a:cubicBezTo>
+                  </a:path>
+                </a:pathLst>
+              </a:custGeom>
+              <a:noFill/>
+              <a:ln w="19050">
+                <a:solidFill>
+                  <a:schemeClr val="accent1"/>
+                </a:solidFill>
+              </a:ln>
+            </p:spPr>
+          </p:sp>
+          <p:sp>
+            <p:nvSpPr>
+              <p:cNvPr id="31" name="Freeform 31"/>
+              <p:cNvSpPr/>
+              <p:nvPr/>
+            </p:nvSpPr>
+            <p:spPr>
+              <a:xfrm>
+                <a:off x="6572250" y="2414588"/>
+                <a:ext cx="22225" cy="133350"/>
+              </a:xfrm>
+              <a:custGeom>
+                <a:avLst/>
+                <a:gdLst/>
+                <a:ahLst/>
+                <a:cxnLst/>
+                <a:rect l="l" t="t" r="r" b="b"/>
+                <a:pathLst>
+                  <a:path w="22225" h="133350">
+                    <a:moveTo>
+                      <a:pt x="0" y="0"/>
+                    </a:moveTo>
+                    <a:cubicBezTo>
+                      <a:pt x="14813" y="3700"/>
+                      <a:pt x="22225" y="25926"/>
+                      <a:pt x="22225" y="66675"/>
+                    </a:cubicBezTo>
+                    <a:cubicBezTo>
+                      <a:pt x="22225" y="107425"/>
+                      <a:pt x="14813" y="129650"/>
+                      <a:pt x="0" y="133350"/>
+                    </a:cubicBezTo>
+                  </a:path>
+                </a:pathLst>
+              </a:custGeom>
+              <a:noFill/>
+              <a:ln w="19050">
+                <a:solidFill>
+                  <a:schemeClr val="accent1"/>
+                </a:solidFill>
+              </a:ln>
+            </p:spPr>
+          </p:sp>
+          <p:sp>
+            <p:nvSpPr>
+              <p:cNvPr id="32" name="Freeform 32"/>
+              <p:cNvSpPr/>
+              <p:nvPr/>
+            </p:nvSpPr>
+            <p:spPr>
+              <a:xfrm>
+                <a:off x="6550025" y="2414588"/>
+                <a:ext cx="22225" cy="133350"/>
+              </a:xfrm>
+              <a:custGeom>
+                <a:avLst/>
+                <a:gdLst/>
+                <a:ahLst/>
+                <a:cxnLst/>
+                <a:rect l="l" t="t" r="r" b="b"/>
+                <a:pathLst>
+                  <a:path w="22225" h="133350">
+                    <a:moveTo>
+                      <a:pt x="22225" y="0"/>
+                    </a:moveTo>
+                    <a:cubicBezTo>
+                      <a:pt x="7412" y="3700"/>
+                      <a:pt x="0" y="25926"/>
+                      <a:pt x="0" y="66675"/>
+                    </a:cubicBezTo>
+                    <a:cubicBezTo>
+                      <a:pt x="0" y="107425"/>
+                      <a:pt x="7412" y="129650"/>
+                      <a:pt x="22225" y="133350"/>
+                    </a:cubicBezTo>
+                  </a:path>
+                </a:pathLst>
+              </a:custGeom>
+              <a:noFill/>
+              <a:ln w="19050">
+                <a:solidFill>
+                  <a:schemeClr val="accent1"/>
+                </a:solidFill>
+              </a:ln>
+            </p:spPr>
+          </p:sp>
+          <p:sp>
+            <p:nvSpPr>
+              <p:cNvPr id="33" name="Freeform 33"/>
+              <p:cNvSpPr/>
+              <p:nvPr/>
+            </p:nvSpPr>
+            <p:spPr>
+              <a:xfrm>
+                <a:off x="6505575" y="2481263"/>
+                <a:ext cx="133350" cy="9525"/>
+              </a:xfrm>
+              <a:custGeom>
+                <a:avLst/>
+                <a:gdLst/>
+                <a:ahLst/>
+                <a:cxnLst/>
+                <a:rect l="l" t="t" r="r" b="b"/>
+                <a:pathLst>
+                  <a:path w="133350" h="9525">
+                    <a:moveTo>
+                      <a:pt x="0" y="0"/>
+                    </a:moveTo>
+                    <a:lnTo>
+                      <a:pt x="133350" y="0"/>
+                    </a:lnTo>
+                  </a:path>
+                </a:pathLst>
+              </a:custGeom>
+              <a:noFill/>
+              <a:ln w="19050">
+                <a:solidFill>
+                  <a:schemeClr val="accent1"/>
+                </a:solidFill>
+              </a:ln>
+            </p:spPr>
+          </p:sp>
+          <p:sp>
+            <p:nvSpPr>
+              <p:cNvPr id="34" name="Freeform 34"/>
+              <p:cNvSpPr/>
+              <p:nvPr/>
+            </p:nvSpPr>
+            <p:spPr>
+              <a:xfrm>
+                <a:off x="6472238" y="2603501"/>
+                <a:ext cx="77788" cy="9525"/>
+              </a:xfrm>
+              <a:custGeom>
+                <a:avLst/>
+                <a:gdLst/>
+                <a:ahLst/>
+                <a:cxnLst/>
+                <a:rect l="l" t="t" r="r" b="b"/>
+                <a:pathLst>
+                  <a:path w="77788" h="9525">
+                    <a:moveTo>
+                      <a:pt x="0" y="0"/>
+                    </a:moveTo>
+                    <a:lnTo>
+                      <a:pt x="77788" y="0"/>
+                    </a:lnTo>
+                  </a:path>
+                </a:pathLst>
+              </a:custGeom>
+              <a:noFill/>
+              <a:ln w="19050">
+                <a:solidFill>
+                  <a:schemeClr val="accent1"/>
+                </a:solidFill>
+              </a:ln>
+            </p:spPr>
+          </p:sp>
+          <p:sp>
+            <p:nvSpPr>
+              <p:cNvPr id="35" name="Freeform 35"/>
+              <p:cNvSpPr/>
+              <p:nvPr/>
+            </p:nvSpPr>
+            <p:spPr>
+              <a:xfrm>
+                <a:off x="6594475" y="2603501"/>
+                <a:ext cx="77788" cy="9525"/>
+              </a:xfrm>
+              <a:custGeom>
+                <a:avLst/>
+                <a:gdLst/>
+                <a:ahLst/>
+                <a:cxnLst/>
+                <a:rect l="l" t="t" r="r" b="b"/>
+                <a:pathLst>
+                  <a:path w="77788" h="9525">
+                    <a:moveTo>
+                      <a:pt x="0" y="0"/>
+                    </a:moveTo>
+                    <a:lnTo>
+                      <a:pt x="77788" y="0"/>
+                    </a:lnTo>
+                  </a:path>
+                </a:pathLst>
+              </a:custGeom>
+              <a:noFill/>
+              <a:ln w="19050">
+                <a:solidFill>
+                  <a:schemeClr val="accent1"/>
+                </a:solidFill>
+              </a:ln>
+            </p:spPr>
+          </p:sp>
+          <p:sp>
+            <p:nvSpPr>
+              <p:cNvPr id="36" name="Freeform 36"/>
+              <p:cNvSpPr/>
+              <p:nvPr/>
+            </p:nvSpPr>
+            <p:spPr>
+              <a:xfrm>
+                <a:off x="6550025" y="2581276"/>
+                <a:ext cx="44450" cy="44450"/>
+              </a:xfrm>
+              <a:custGeom>
+                <a:avLst/>
+                <a:gdLst/>
+                <a:ahLst/>
+                <a:cxnLst/>
+                <a:rect l="l" t="t" r="r" b="b"/>
+                <a:pathLst>
+                  <a:path w="44450" h="44450">
+                    <a:moveTo>
+                      <a:pt x="0" y="22225"/>
+                    </a:moveTo>
+                    <a:cubicBezTo>
+                      <a:pt x="0" y="34500"/>
+                      <a:pt x="9950" y="44450"/>
+                      <a:pt x="22225" y="44450"/>
+                    </a:cubicBezTo>
+                    <a:cubicBezTo>
+                      <a:pt x="34500" y="44450"/>
+                      <a:pt x="44450" y="34500"/>
+                      <a:pt x="44450" y="22225"/>
+                    </a:cubicBezTo>
+                    <a:cubicBezTo>
+                      <a:pt x="44450" y="9950"/>
+                      <a:pt x="34500" y="0"/>
+                      <a:pt x="22225" y="0"/>
+                    </a:cubicBezTo>
+                    <a:cubicBezTo>
+                      <a:pt x="9950" y="0"/>
+                      <a:pt x="0" y="9950"/>
+                      <a:pt x="0" y="22225"/>
+                    </a:cubicBezTo>
+                  </a:path>
+                </a:pathLst>
+              </a:custGeom>
+              <a:noFill/>
+              <a:ln w="19050">
+                <a:solidFill>
+                  <a:schemeClr val="accent1"/>
+                </a:solidFill>
+              </a:ln>
+            </p:spPr>
+          </p:sp>
+          <p:sp>
+            <p:nvSpPr>
+              <p:cNvPr id="37" name="Freeform 37"/>
+              <p:cNvSpPr/>
+              <p:nvPr/>
+            </p:nvSpPr>
+            <p:spPr>
+              <a:xfrm>
+                <a:off x="6572250" y="2547938"/>
+                <a:ext cx="9525" cy="33338"/>
+              </a:xfrm>
+              <a:custGeom>
+                <a:avLst/>
+                <a:gdLst/>
+                <a:ahLst/>
+                <a:cxnLst/>
+                <a:rect l="l" t="t" r="r" b="b"/>
+                <a:pathLst>
+                  <a:path w="9525" h="33338">
+                    <a:moveTo>
+                      <a:pt x="0" y="0"/>
+                    </a:moveTo>
+                    <a:lnTo>
+                      <a:pt x="0" y="33338"/>
+                    </a:lnTo>
+                  </a:path>
+                </a:pathLst>
+              </a:custGeom>
+              <a:noFill/>
+              <a:ln w="19050">
+                <a:solidFill>
+                  <a:schemeClr val="accent1"/>
+                </a:solidFill>
+              </a:ln>
+            </p:spPr>
+          </p:sp>
+        </p:grpSp>
+        <p:sp>
+          <p:nvSpPr>
+            <p:cNvPr id="39" name="TextBox 39"/>
+            <p:cNvSpPr txBox="1"/>
+            <p:nvPr/>
+          </p:nvSpPr>
+          <p:spPr>
+            <a:xfrm>
+              <a:off x="6791706" y="2396490"/>
+              <a:ext cx="2518440" cy="352044"/>
+            </a:xfrm>
+            <a:prstGeom prst="rect">
+              <a:avLst/>
+            </a:prstGeom>
+            <a:noFill/>
+            <a:ln>
+              <a:noFill/>
+            </a:ln>
+          </p:spPr>
+          <p:txBody>
+            <a:bodyPr wrap="none" lIns="0" tIns="0" rIns="0" bIns="0" anchor="t" anchorCtr="0">
+              <a:spAutoFit/>
+            </a:bodyPr>
+            <a:lstStyle/>
+            <a:p>
+              <a:pPr algn="l"/>
+              <a:r>
+                <a:rPr lang="zh-CN" sz="1800" b="1" dirty="0">
+                  <a:solidFill>
+                    <a:schemeClr val="accent1"/>
+                  </a:solidFill>
+                  <a:latin typeface="Segoe UI"/>
+                  <a:ea typeface="Microsoft YaHei"/>
+                  <a:cs typeface="Segoe UI"/>
+                </a:rPr>
+                <a:t>2 四个自研 MCP 服务</a:t>
+              </a:r>
+            </a:p>
+          </p:txBody>
+        </p:sp>
+        <p:sp>
+          <p:nvSpPr>
+            <p:cNvPr id="40" name="TextBox 40"/>
+            <p:cNvSpPr txBox="1"/>
+            <p:nvPr/>
+          </p:nvSpPr>
+          <p:spPr>
+            <a:xfrm>
+              <a:off x="6432042" y="2807018"/>
+              <a:ext cx="3845623" cy="530733"/>
+            </a:xfrm>
+            <a:prstGeom prst="rect">
+              <a:avLst/>
+            </a:prstGeom>
+            <a:noFill/>
+            <a:ln>
+              <a:noFill/>
+            </a:ln>
+          </p:spPr>
+          <p:txBody>
+            <a:bodyPr wrap="square" lIns="0" tIns="0" rIns="0" bIns="0" anchor="t" anchorCtr="0"/>
+            <a:lstStyle/>
+            <a:p>
+              <a:pPr algn="l">
+                <a:lnSpc>
+                  <a:spcPts val="2100"/>
+                </a:lnSpc>
+              </a:pPr>
+              <a:r>
+                <a:rPr lang="zh-CN" sz="1350" dirty="0">
+                  <a:solidFill>
+                    <a:schemeClr val="dk1"/>
+                  </a:solidFill>
+                  <a:latin typeface="Segoe UI"/>
+                  <a:ea typeface="Microsoft YaHei"/>
+                  <a:cs typeface="Segoe UI"/>
+                </a:rPr>
+                <a:t>文献检索、引用核对、绘图、RECIPE 前驱体预测；</a:t>
+              </a:r>
+              <a:r>
+                <a:rPr lang="zh-CN" sz="1350" dirty="0">
+                  <a:solidFill>
+                    <a:schemeClr val="dk1"/>
+                  </a:solidFill>
+                  <a:latin typeface="Segoe UI"/>
+                  <a:ea typeface="Microsoft YaHei"/>
+                  <a:cs typeface="Segoe UI"/>
+                </a:rPr>
+                <a:t>全部可离线测试，每次调用写入审计日志。</a:t>
+              </a:r>
+            </a:p>
+          </p:txBody>
+        </p:sp>
+        <p:sp>
+          <p:nvSpPr>
+            <p:cNvPr id="41" name="Rectangle 41"/>
+            <p:cNvSpPr/>
+            <p:nvPr/>
+          </p:nvSpPr>
+          <p:spPr>
+            <a:xfrm>
+              <a:off x="6210300" y="3962400"/>
+              <a:ext cx="5295900" cy="1638300"/>
+            </a:xfrm>
+            <a:prstGeom prst="rect">
+              <a:avLst/>
+            </a:prstGeom>
+            <a:solidFill>
+              <a:schemeClr val="lt2"/>
+            </a:solidFill>
+            <a:ln>
+              <a:noFill/>
+            </a:ln>
+          </p:spPr>
+        </p:sp>
+        <p:grpSp>
+          <p:nvGrpSpPr>
+            <p:cNvPr id="44" name="Group 44"/>
+            <p:cNvGrpSpPr/>
+            <p:nvPr/>
+          </p:nvGrpSpPr>
+          <p:grpSpPr>
+            <a:xfrm>
+              <a:off x="6483350" y="4205288"/>
+              <a:ext cx="177801" cy="200025"/>
+              <a:chOff x="6483350" y="4205288"/>
+              <a:chExt cx="177801" cy="200025"/>
+            </a:xfrm>
+          </p:grpSpPr>
+          <p:sp>
+            <p:nvSpPr>
+              <p:cNvPr id="42" name="Freeform 42"/>
+              <p:cNvSpPr/>
+              <p:nvPr/>
+            </p:nvSpPr>
+            <p:spPr>
+              <a:xfrm>
+                <a:off x="6483350" y="4205288"/>
+                <a:ext cx="177801" cy="100013"/>
+              </a:xfrm>
+              <a:custGeom>
+                <a:avLst/>
+                <a:gdLst/>
+                <a:ahLst/>
+                <a:cxnLst/>
+                <a:rect l="l" t="t" r="r" b="b"/>
+                <a:pathLst>
+                  <a:path w="177801" h="100013">
+                    <a:moveTo>
+                      <a:pt x="0" y="100013"/>
+                    </a:moveTo>
+                    <a:lnTo>
+                      <a:pt x="0" y="66675"/>
+                    </a:lnTo>
+                    <a:cubicBezTo>
+                      <a:pt x="0" y="48263"/>
+                      <a:pt x="14926" y="33338"/>
+                      <a:pt x="33338" y="33338"/>
+                    </a:cubicBezTo>
+                    <a:lnTo>
+                      <a:pt x="177801" y="33338"/>
+                    </a:lnTo>
+                    <a:moveTo>
+                      <a:pt x="144463" y="0"/>
+                    </a:moveTo>
+                    <a:lnTo>
+                      <a:pt x="177801" y="33338"/>
+                    </a:lnTo>
+                    <a:lnTo>
+                      <a:pt x="144463" y="66675"/>
+                    </a:lnTo>
+                  </a:path>
+                </a:pathLst>
+              </a:custGeom>
+              <a:noFill/>
+              <a:ln w="19050">
+                <a:solidFill>
+                  <a:schemeClr val="accent1"/>
+                </a:solidFill>
+              </a:ln>
+            </p:spPr>
+          </p:sp>
+          <p:sp>
+            <p:nvSpPr>
+              <p:cNvPr id="43" name="Freeform 43"/>
+              <p:cNvSpPr/>
+              <p:nvPr/>
+            </p:nvSpPr>
+            <p:spPr>
+              <a:xfrm>
+                <a:off x="6483350" y="4305300"/>
+                <a:ext cx="177801" cy="100013"/>
+              </a:xfrm>
+              <a:custGeom>
+                <a:avLst/>
+                <a:gdLst/>
+                <a:ahLst/>
+                <a:cxnLst/>
+                <a:rect l="l" t="t" r="r" b="b"/>
+                <a:pathLst>
+                  <a:path w="177801" h="100013">
+                    <a:moveTo>
+                      <a:pt x="177801" y="0"/>
+                    </a:moveTo>
+                    <a:lnTo>
+                      <a:pt x="177801" y="33338"/>
+                    </a:lnTo>
+                    <a:cubicBezTo>
+                      <a:pt x="177801" y="51749"/>
+                      <a:pt x="162875" y="66675"/>
+                      <a:pt x="144463" y="66675"/>
+                    </a:cubicBezTo>
+                    <a:lnTo>
+                      <a:pt x="0" y="66675"/>
+                    </a:lnTo>
+                    <a:moveTo>
+                      <a:pt x="33338" y="100013"/>
+                    </a:moveTo>
+                    <a:lnTo>
+                      <a:pt x="0" y="66675"/>
+                    </a:lnTo>
+                    <a:lnTo>
+                      <a:pt x="33338" y="33338"/>
+                    </a:lnTo>
+                  </a:path>
+                </a:pathLst>
+              </a:custGeom>
+              <a:noFill/>
+              <a:ln w="19050">
+                <a:solidFill>
+                  <a:schemeClr val="accent1"/>
+                </a:solidFill>
+              </a:ln>
+            </p:spPr>
+          </p:sp>
+        </p:grpSp>
+        <p:sp>
+          <p:nvSpPr>
+            <p:cNvPr id="45" name="TextBox 45"/>
+            <p:cNvSpPr txBox="1"/>
+            <p:nvPr/>
+          </p:nvSpPr>
+          <p:spPr>
+            <a:xfrm>
+              <a:off x="6791706" y="4187190"/>
+              <a:ext cx="2778873" cy="352044"/>
+            </a:xfrm>
+            <a:prstGeom prst="rect">
+              <a:avLst/>
+            </a:prstGeom>
+            <a:noFill/>
+            <a:ln>
+              <a:noFill/>
+            </a:ln>
+          </p:spPr>
+          <p:txBody>
+            <a:bodyPr wrap="none" lIns="0" tIns="0" rIns="0" bIns="0" anchor="t" anchorCtr="0">
+              <a:spAutoFit/>
+            </a:bodyPr>
+            <a:lstStyle/>
+            <a:p>
+              <a:pPr algn="l"/>
+              <a:r>
+                <a:rPr lang="zh-CN" sz="1800" b="1" dirty="0">
+                  <a:solidFill>
+                    <a:schemeClr val="accent1"/>
+                  </a:solidFill>
+                  <a:latin typeface="Segoe UI"/>
+                  <a:ea typeface="Microsoft YaHei"/>
+                  <a:cs typeface="Segoe UI"/>
+                </a:rPr>
+                <a:t>4 一键安装、冒烟、复跑</a:t>
+              </a:r>
+            </a:p>
+          </p:txBody>
+        </p:sp>
+        <p:sp>
+          <p:nvSpPr>
+            <p:cNvPr id="46" name="TextBox 46"/>
+            <p:cNvSpPr txBox="1"/>
+            <p:nvPr/>
+          </p:nvSpPr>
+          <p:spPr>
+            <a:xfrm>
+              <a:off x="6432042" y="4597718"/>
+              <a:ext cx="4968621" cy="530733"/>
+            </a:xfrm>
+            <a:prstGeom prst="rect">
+              <a:avLst/>
+            </a:prstGeom>
+            <a:noFill/>
+            <a:ln>
+              <a:noFill/>
+            </a:ln>
+          </p:spPr>
+          <p:txBody>
+            <a:bodyPr wrap="square" lIns="0" tIns="0" rIns="0" bIns="0" anchor="t" anchorCtr="0"/>
+            <a:lstStyle/>
+            <a:p>
+              <a:pPr algn="l">
+                <a:lnSpc>
+                  <a:spcPts val="2100"/>
+                </a:lnSpc>
+              </a:pPr>
+              <a:r>
+                <a:rPr lang="zh-CN" sz="1350" dirty="0">
+                  <a:solidFill>
+                    <a:schemeClr val="dk1"/>
+                  </a:solidFill>
+                  <a:latin typeface="Segoe UI"/>
+                  <a:ea typeface="Microsoft YaHei"/>
+                  <a:cs typeface="Segoe UI"/>
+                </a:rPr>
+                <a:t>install.sh 锁定依赖；smoke test 无网络、无 LLM，1–2 分钟；</a:t>
+              </a:r>
+              <a:r>
+                <a:rPr lang="zh-CN" sz="1350" dirty="0">
+                  <a:solidFill>
+                    <a:schemeClr val="dk1"/>
+                  </a:solidFill>
+                  <a:latin typeface="Segoe UI"/>
+                  <a:ea typeface="Microsoft YaHei"/>
+                  <a:cs typeface="Segoe UI"/>
+                </a:rPr>
+                <a:t>reproduce_core 同一主题重跑，关卡全过才返回 0。</a:t>
+              </a:r>
+            </a:p>
+          </p:txBody>
+        </p:sp>
+        <p:sp>
+          <p:nvSpPr>
+            <p:cNvPr id="47" name="Rectangle 47"/>
+            <p:cNvSpPr/>
+            <p:nvPr/>
+          </p:nvSpPr>
+          <p:spPr>
+            <a:xfrm>
+              <a:off x="685800" y="5753100"/>
+              <a:ext cx="10820400" cy="571500"/>
+            </a:xfrm>
+            <a:prstGeom prst="rect">
+              <a:avLst/>
+            </a:prstGeom>
+            <a:solidFill>
+              <a:schemeClr val="lt1"/>
+            </a:solidFill>
+            <a:ln w="9525">
+              <a:solidFill>
+                <a:schemeClr val="accent4"/>
+              </a:solidFill>
+            </a:ln>
+          </p:spPr>
+        </p:sp>
+        <p:grpSp>
+          <p:nvGrpSpPr>
+            <p:cNvPr id="51" name="Group 51"/>
+            <p:cNvGrpSpPr/>
+            <p:nvPr/>
+          </p:nvGrpSpPr>
+          <p:grpSpPr>
+            <a:xfrm>
+              <a:off x="897579" y="5935146"/>
+              <a:ext cx="224134" cy="192560"/>
+              <a:chOff x="897579" y="5935146"/>
+              <a:chExt cx="224134" cy="192560"/>
+            </a:xfrm>
+          </p:grpSpPr>
+          <p:sp>
+            <p:nvSpPr>
+              <p:cNvPr id="48" name="Freeform 48"/>
+              <p:cNvSpPr/>
+              <p:nvPr/>
+            </p:nvSpPr>
+            <p:spPr>
+              <a:xfrm>
+                <a:off x="1009650" y="6005513"/>
                 <a:ext cx="9525" cy="44450"/>
               </a:xfrm>
               <a:custGeom>
@@ -6618,13 +7527,13 @@
           </p:sp>
           <p:sp>
             <p:nvSpPr>
-              <p:cNvPr id="23" name="Freeform 23"/>
+              <p:cNvPr id="49" name="Freeform 49"/>
               <p:cNvSpPr/>
               <p:nvPr/>
             </p:nvSpPr>
             <p:spPr>
               <a:xfrm>
-                <a:off x="6460179" y="4220646"/>
+                <a:off x="897579" y="5935146"/>
                 <a:ext cx="224134" cy="192560"/>
               </a:xfrm>
               <a:custGeom>
@@ -6690,13 +7599,13 @@
           </p:sp>
           <p:sp>
             <p:nvSpPr>
-              <p:cNvPr id="24" name="Freeform 24"/>
+              <p:cNvPr id="50" name="Freeform 50"/>
               <p:cNvSpPr/>
               <p:nvPr/>
             </p:nvSpPr>
             <p:spPr>
               <a:xfrm>
-                <a:off x="6572250" y="4368801"/>
+                <a:off x="1009650" y="6083301"/>
                 <a:ext cx="9525" cy="9525"/>
               </a:xfrm>
               <a:custGeom>
@@ -6727,54 +7636,14 @@
         </p:grpSp>
         <p:sp>
           <p:nvSpPr>
-            <p:cNvPr id="26" name="TextBox 26"/>
-            <p:cNvSpPr txBox="1"/>
-            <p:nvPr/>
-          </p:nvSpPr>
-          <p:spPr>
-            <a:xfrm>
-              <a:off x="6793992" y="4254818"/>
-              <a:ext cx="777011" cy="264033"/>
-            </a:xfrm>
-            <a:prstGeom prst="rect">
-              <a:avLst/>
-            </a:prstGeom>
-            <a:noFill/>
-            <a:ln>
-              <a:noFill/>
-            </a:ln>
-          </p:spPr>
-          <p:txBody>
-            <a:bodyPr wrap="none" lIns="0" tIns="0" rIns="0" bIns="0" anchor="t" anchorCtr="0">
-              <a:spAutoFit/>
-            </a:bodyPr>
-            <a:lstStyle/>
-            <a:p>
-              <a:pPr algn="l"/>
-              <a:r>
-                <a:rPr lang="zh-CN" sz="1350" b="1" dirty="0">
-                  <a:solidFill>
-                    <a:schemeClr val="accent1"/>
-                  </a:solidFill>
-                  <a:latin typeface="Segoe UI"/>
-                  <a:ea typeface="Microsoft YaHei"/>
-                  <a:cs typeface="Segoe UI"/>
-                </a:rPr>
-                <a:t>诚实说明</a:t>
-              </a:r>
-            </a:p>
-          </p:txBody>
-        </p:sp>
-        <p:sp>
-          <p:nvSpPr>
-            <p:cNvPr id="27" name="TextBox 27"/>
-            <p:cNvSpPr txBox="1"/>
-            <p:nvPr/>
-          </p:nvSpPr>
-          <p:spPr>
-            <a:xfrm>
-              <a:off x="6432042" y="4559618"/>
-              <a:ext cx="4059936" cy="759333"/>
+            <p:cNvPr id="52" name="TextBox 52"/>
+            <p:cNvSpPr txBox="1"/>
+            <p:nvPr/>
+          </p:nvSpPr>
+          <p:spPr>
+            <a:xfrm>
+              <a:off x="1250442" y="5855018"/>
+              <a:ext cx="9374886" cy="492633"/>
             </a:xfrm>
             <a:prstGeom prst="rect">
               <a:avLst/>
@@ -6790,10 +7659,21 @@
             <a:p>
               <a:pPr algn="l">
                 <a:lnSpc>
-                  <a:spcPts val="1950"/>
+                  <a:spcPts val="1800"/>
                 </a:lnSpc>
               </a:pPr>
               <a:r>
+                <a:rPr lang="zh-CN" sz="1350" b="1" dirty="0">
+                  <a:solidFill>
+                    <a:schemeClr val="accent1"/>
+                  </a:solidFill>
+                  <a:latin typeface="Segoe UI"/>
+                  <a:ea typeface="Microsoft YaHei"/>
+                  <a:cs typeface="Segoe UI"/>
+                </a:rPr>
+                <a:t>边界</a:t>
+              </a:r>
+              <a:r>
                 <a:rPr lang="zh-CN" sz="1350" dirty="0">
                   <a:solidFill>
                     <a:schemeClr val="dk1"/>
@@ -6802,7 +7682,7 @@
                   <a:ea typeface="Microsoft YaHei"/>
                   <a:cs typeface="Segoe UI"/>
                 </a:rPr>
-                <a:t>大模型步骤不可逐字复现；案例 3 终审为</a:t>
+                <a:t xml:space="preserve"> 目标相仅 1 篇直接报道；大模型步骤不可逐字复现，以关卡全部通过为复现判据。</a:t>
               </a:r>
               <a:r>
                 <a:rPr lang="zh-CN" sz="1350" dirty="0">
@@ -6813,18 +7693,7 @@
                   <a:ea typeface="Microsoft YaHei"/>
                   <a:cs typeface="Segoe UI"/>
                 </a:rPr>
-                <a:t>同模型冷启动 provisional；模型候选均待实验验证。</a:t>
-              </a:r>
-              <a:r>
-                <a:rPr lang="zh-CN" sz="1350" dirty="0">
-                  <a:solidFill>
-                    <a:schemeClr val="dk1"/>
-                  </a:solidFill>
-                  <a:latin typeface="Segoe UI"/>
-                  <a:ea typeface="Microsoft YaHei"/>
-                  <a:cs typeface="Segoe UI"/>
-                </a:rPr>
-                <a:t>复现以证据链与质量关卡一致为判据。</a:t>
+                <a:t>09-03 用同一系统对三个新主题各冷启动一次（LLZO 16 页 · BaZn2Si2O7 4 页 · Ba–Y–Zn–Si–O 相图 35 页），随包提交。</a:t>
               </a:r>
             </a:p>
           </p:txBody>
@@ -6832,7 +7701,7 @@
       </p:grpSp>
       <p:grpSp>
         <p:nvGrpSpPr>
-          <p:cNvPr id="31" name="Group 31"/>
+          <p:cNvPr id="56" name="Group 56"/>
           <p:cNvGrpSpPr/>
           <p:nvPr/>
         </p:nvGrpSpPr>
@@ -6846,7 +7715,7 @@
         </p:grpSpPr>
         <p:sp>
           <p:nvSpPr>
-            <p:cNvPr id="29" name="TextBox 29"/>
+            <p:cNvPr id="54" name="TextBox 54"/>
             <p:cNvSpPr txBox="1"/>
             <p:nvPr/>
           </p:nvSpPr>
@@ -6886,7 +7755,7 @@
         </p:sp>
         <p:sp>
           <p:nvSpPr>
-            <p:cNvPr id="30" name="TextBox 30"/>
+            <p:cNvPr id="55" name="TextBox 55"/>
             <p:cNvSpPr txBox="1"/>
             <p:nvPr/>
           </p:nvSpPr>
@@ -7021,9 +7890,9 @@
         <p:grpSpPr>
           <a:xfrm>
             <a:off x="670560" y="590550"/>
-            <a:ext cx="8511540" cy="586740"/>
+            <a:ext cx="10631805" cy="586740"/>
             <a:chOff x="670560" y="590550"/>
-            <a:chExt cx="8511540" cy="586740"/>
+            <a:chExt cx="10631805" cy="586740"/>
           </a:xfrm>
         </p:grpSpPr>
         <p:sp>
@@ -7035,7 +7904,7 @@
           <p:spPr>
             <a:xfrm>
               <a:off x="670560" y="590550"/>
-              <a:ext cx="8511540" cy="586740"/>
+              <a:ext cx="10631805" cy="586740"/>
             </a:xfrm>
             <a:prstGeom prst="rect">
               <a:avLst/>
@@ -7061,7 +7930,7 @@
                   <a:ea typeface="Microsoft YaHei"/>
                   <a:cs typeface="Segoe UI"/>
                 </a:rPr>
-                <a:t>应用价值：合成建议可追溯、可执行、可回写</a:t>
+                <a:t>应用价值：让每一条合成建议都可追溯、可执行、可回写</a:t>
               </a:r>
             </a:p>
           </p:txBody>
@@ -7513,7 +8382,7 @@
           <p:spPr>
             <a:xfrm>
               <a:off x="907542" y="3759518"/>
-              <a:ext cx="2645474" cy="1749933"/>
+              <a:ext cx="2928366" cy="1749933"/>
             </a:xfrm>
             <a:prstGeom prst="rect">
               <a:avLst/>
@@ -7568,7 +8437,7 @@
                   <a:ea typeface="Microsoft YaHei"/>
                   <a:cs typeface="Segoe UI"/>
                 </a:rPr>
-                <a:t xml:space="preserve">案例 3：513 / 513 </a:t>
+                <a:t>51 篇文献逐条核对，28 条合成条件</a:t>
               </a:r>
               <a:r>
                 <a:rPr lang="zh-CN" sz="1350" dirty="0">
@@ -7579,7 +8448,7 @@
                   <a:ea typeface="Microsoft YaHei"/>
                   <a:cs typeface="Segoe UI"/>
                 </a:rPr>
-                <a:t>LLZO：368 / 368，引用审计 PASS</a:t>
+                <a:t>逐字段比较，同类体系单独成节</a:t>
               </a:r>
             </a:p>
             <a:p>
@@ -7606,7 +8475,7 @@
                   <a:ea typeface="Microsoft YaHei"/>
                   <a:cs typeface="Segoe UI"/>
                 </a:rPr>
-                <a:t>每条结论可点开 DOI / 原文段落</a:t>
+                <a:t>每条结论可点开 DOI 与原文段落，</a:t>
               </a:r>
               <a:r>
                 <a:rPr lang="zh-CN" sz="1350" dirty="0">
@@ -7644,7 +8513,7 @@
                   <a:ea typeface="Microsoft YaHei"/>
                   <a:cs typeface="Segoe UI"/>
                 </a:rPr>
-                <a:t>35 / 16 页终稿衔接</a:t>
+                <a:t>前人结论汇总 + 相图讨论，直接进入</a:t>
               </a:r>
               <a:r>
                 <a:rPr lang="zh-CN" sz="1350" dirty="0">
@@ -7655,7 +8524,7 @@
                   <a:ea typeface="Microsoft YaHei"/>
                   <a:cs typeface="Segoe UI"/>
                 </a:rPr>
-                <a:t>证据边界、问题与实验设计</a:t>
+                <a:t>课题设计而非再读一遍文献</a:t>
               </a:r>
             </a:p>
           </p:txBody>
@@ -7670,9 +8539,9 @@
         <p:grpSpPr>
           <a:xfrm>
             <a:off x="4381500" y="3200400"/>
-            <a:ext cx="3429000" cy="2571750"/>
+            <a:ext cx="3570161" cy="2571750"/>
             <a:chOff x="4381500" y="3200400"/>
-            <a:chExt cx="3429000" cy="2571750"/>
+            <a:chExt cx="3570161" cy="2571750"/>
           </a:xfrm>
         </p:grpSpPr>
         <p:sp>
@@ -7901,7 +8770,7 @@
           <p:spPr>
             <a:xfrm>
               <a:off x="4603242" y="3759518"/>
-              <a:ext cx="2731198" cy="1749933"/>
+              <a:ext cx="3348419" cy="1749933"/>
             </a:xfrm>
             <a:prstGeom prst="rect">
               <a:avLst/>
@@ -7956,7 +8825,7 @@
                   <a:ea typeface="Microsoft YaHei"/>
                   <a:cs typeface="Segoe UI"/>
                 </a:rPr>
-                <a:t>方案包含前驱体、条件与表征，</a:t>
+                <a:t>方案 = 前驱体 + 条件 + 表征 + 失败判据，</a:t>
               </a:r>
               <a:r>
                 <a:rPr lang="zh-CN" sz="1350" dirty="0">
@@ -7967,7 +8836,7 @@
                   <a:ea typeface="Microsoft YaHei"/>
                   <a:cs typeface="Segoe UI"/>
                 </a:rPr>
-                <a:t>失败判据也是结构化可调度对象</a:t>
+                <a:t>全部是结构化、可调度的对象</a:t>
               </a:r>
             </a:p>
             <a:p>
@@ -8424,7 +9293,7 @@
           <p:spPr>
             <a:xfrm>
               <a:off x="8298942" y="3759518"/>
-              <a:ext cx="2559748" cy="1749933"/>
+              <a:ext cx="3099816" cy="1749933"/>
             </a:xfrm>
             <a:prstGeom prst="rect">
               <a:avLst/>
@@ -8479,7 +9348,7 @@
                   <a:ea typeface="Microsoft YaHei"/>
                   <a:cs typeface="Segoe UI"/>
                 </a:rPr>
-                <a:t>尚无相纯四元相的可复现报道，</a:t>
+                <a:t>只有 1 篇直接报道的目标相，也得到</a:t>
               </a:r>
               <a:r>
                 <a:rPr lang="zh-CN" sz="1350" dirty="0">
@@ -8490,7 +9359,7 @@
                   <a:ea typeface="Microsoft YaHei"/>
                   <a:cs typeface="Segoe UI"/>
                 </a:rPr>
-                <a:t>仍得到 3 个可证伪实验方向</a:t>
+                <a:t>4 个实验方向与 7 种化合物的前驱体候选</a:t>
               </a:r>
             </a:p>
             <a:p>
@@ -8555,7 +9424,7 @@
                   <a:ea typeface="Microsoft YaHei"/>
                   <a:cs typeface="Segoe UI"/>
                 </a:rPr>
-                <a:t>LLZO 再给出 3 项判别实验，</a:t>
+                <a:t>先做局部相图再做单一配方，</a:t>
               </a:r>
               <a:r>
                 <a:rPr lang="zh-CN" sz="1350" dirty="0">
@@ -8566,7 +9435,7 @@
                   <a:ea typeface="Microsoft YaHei"/>
                   <a:cs typeface="Segoe UI"/>
                 </a:rPr>
-                <a:t>把探索预算花在最有信息增益处</a:t>
+                <a:t>把探索预算花在最有发现价值处</a:t>
               </a:r>
             </a:p>
           </p:txBody>
@@ -8574,16 +9443,16 @@
       </p:grpSp>
       <p:grpSp>
         <p:nvGrpSpPr>
-          <p:cNvPr id="43" name="Group 43"/>
+          <p:cNvPr id="42" name="Group 42"/>
           <p:cNvGrpSpPr/>
           <p:nvPr/>
         </p:nvGrpSpPr>
         <p:grpSpPr>
           <a:xfrm>
             <a:off x="678942" y="6007418"/>
-            <a:ext cx="10834116" cy="264033"/>
+            <a:ext cx="10475753" cy="264033"/>
             <a:chOff x="678942" y="6007418"/>
-            <a:chExt cx="10834116" cy="264033"/>
+            <a:chExt cx="10475753" cy="264033"/>
           </a:xfrm>
         </p:grpSpPr>
         <p:sp>
@@ -8595,7 +9464,7 @@
           <p:spPr>
             <a:xfrm>
               <a:off x="678942" y="6007418"/>
-              <a:ext cx="4720704" cy="264033"/>
+              <a:ext cx="10475753" cy="264033"/>
             </a:xfrm>
             <a:prstGeom prst="rect">
               <a:avLst/>
@@ -8632,37 +9501,8 @@
                   <a:ea typeface="Microsoft YaHei"/>
                   <a:cs typeface="Segoe UI"/>
                 </a:rPr>
-                <a:t xml:space="preserve"> 跨模型审稿 · 实验验证回写 · 扩展温度 / 气氛预测</a:t>
-              </a:r>
-            </a:p>
-          </p:txBody>
-        </p:sp>
-        <p:sp>
-          <p:nvSpPr>
-            <p:cNvPr id="42" name="TextBox 42"/>
-            <p:cNvSpPr txBox="1"/>
-            <p:nvPr/>
-          </p:nvSpPr>
-          <p:spPr>
-            <a:xfrm>
-              <a:off x="8580151" y="6007418"/>
-              <a:ext cx="2932907" cy="264033"/>
-            </a:xfrm>
-            <a:prstGeom prst="rect">
-              <a:avLst/>
-            </a:prstGeom>
-            <a:noFill/>
-            <a:ln>
-              <a:noFill/>
-            </a:ln>
-          </p:spPr>
-          <p:txBody>
-            <a:bodyPr wrap="none" lIns="0" tIns="0" rIns="0" bIns="0" anchor="t" anchorCtr="0">
-              <a:spAutoFit/>
-            </a:bodyPr>
-            <a:lstStyle/>
-            <a:p>
-              <a:pPr algn="r"/>
+                <a:t xml:space="preserve"> 接入跨模型审稿 · 对四个方向开展合成实验并回写为证据 · 扩展温度 / 气氛条件预测 </a:t>
+              </a:r>
               <a:r>
                 <a:rPr lang="zh-CN" sz="1350" b="1" dirty="0">
                   <a:solidFill>
@@ -8691,7 +9531,7 @@
       </p:grpSp>
       <p:grpSp>
         <p:nvGrpSpPr>
-          <p:cNvPr id="46" name="Group 46"/>
+          <p:cNvPr id="45" name="Group 45"/>
           <p:cNvGrpSpPr/>
           <p:nvPr/>
         </p:nvGrpSpPr>
@@ -8705,7 +9545,7 @@
         </p:grpSpPr>
         <p:sp>
           <p:nvSpPr>
-            <p:cNvPr id="44" name="TextBox 44"/>
+            <p:cNvPr id="43" name="TextBox 43"/>
             <p:cNvSpPr txBox="1"/>
             <p:nvPr/>
           </p:nvSpPr>
@@ -8745,7 +9585,7 @@
         </p:sp>
         <p:sp>
           <p:nvSpPr>
-            <p:cNvPr id="45" name="TextBox 45"/>
+            <p:cNvPr id="44" name="TextBox 44"/>
             <p:cNvSpPr txBox="1"/>
             <p:nvPr/>
           </p:nvSpPr>
@@ -10238,9 +11078,9 @@
         <p:grpSpPr>
           <a:xfrm>
             <a:off x="670560" y="590550"/>
-            <a:ext cx="11903964" cy="586740"/>
+            <a:ext cx="12328017" cy="586740"/>
             <a:chOff x="670560" y="590550"/>
-            <a:chExt cx="11903964" cy="586740"/>
+            <a:chExt cx="12328017" cy="586740"/>
           </a:xfrm>
         </p:grpSpPr>
         <p:sp>
@@ -10252,7 +11092,7 @@
           <p:spPr>
             <a:xfrm>
               <a:off x="670560" y="590550"/>
-              <a:ext cx="11903964" cy="586740"/>
+              <a:ext cx="12328017" cy="586740"/>
             </a:xfrm>
             <a:prstGeom prst="rect">
               <a:avLst/>
@@ -10278,7 +11118,7 @@
                   <a:ea typeface="Microsoft YaHei"/>
                   <a:cs typeface="Segoe UI"/>
                 </a:rPr>
-                <a:t>合成条件与前人经验散落在文献里，站在巨人肩膀上才有新发现</a:t>
+                <a:t>合成条件与失败边界散落在文献里：先找全、核对清，再谈新发现</a:t>
               </a:r>
             </a:p>
           </p:txBody>
@@ -10412,7 +11252,7 @@
                   <a:ea typeface="Microsoft YaHei"/>
                   <a:cs typeface="Segoe UI"/>
                 </a:rPr>
-                <a:t>。科学问题本身也是探索出来的：一个来自团队自主探索，</a:t>
+                <a:t>。两个案例的问题来源不同：一个由团队自主探索确定，</a:t>
               </a:r>
               <a:r>
                 <a:rPr lang="zh-CN" sz="1950" dirty="0">
@@ -10423,7 +11263,7 @@
                   <a:ea typeface="Microsoft YaHei"/>
                   <a:cs typeface="Segoe UI"/>
                 </a:rPr>
-                <a:t>一个来自领域专家推荐。</a:t>
+                <a:t>一个由领域专家推荐。</a:t>
               </a:r>
             </a:p>
           </p:txBody>
@@ -21962,9 +22802,9 @@
         <p:grpSpPr>
           <a:xfrm>
             <a:off x="670560" y="590550"/>
-            <a:ext cx="10610602" cy="586740"/>
+            <a:ext cx="11204277" cy="586740"/>
             <a:chOff x="670560" y="590550"/>
-            <a:chExt cx="10610602" cy="586740"/>
+            <a:chExt cx="11204277" cy="586740"/>
           </a:xfrm>
         </p:grpSpPr>
         <p:sp>
@@ -21976,7 +22816,7 @@
           <p:spPr>
             <a:xfrm>
               <a:off x="670560" y="590550"/>
-              <a:ext cx="10610602" cy="586740"/>
+              <a:ext cx="11204277" cy="586740"/>
             </a:xfrm>
             <a:prstGeom prst="rect">
               <a:avLst/>
@@ -22002,7 +22842,7 @@
                   <a:ea typeface="Microsoft YaHei"/>
                   <a:cs typeface="Segoe UI"/>
                 </a:rPr>
-                <a:t>相图导向冷启动：513 篇文献闭环，三个实验方向可检验</a:t>
+                <a:t>纯主题冷启动：51 篇文献全部核验、100 条结论全部可追溯</a:t>
               </a:r>
             </a:p>
           </p:txBody>
@@ -22039,9 +22879,9 @@
         <p:grpSpPr>
           <a:xfrm>
             <a:off x="675894" y="1370648"/>
-            <a:ext cx="9467660" cy="743331"/>
+            <a:ext cx="9881235" cy="743331"/>
             <a:chOff x="675894" y="1370648"/>
-            <a:chExt cx="9467660" cy="743331"/>
+            <a:chExt cx="9881235" cy="743331"/>
           </a:xfrm>
         </p:grpSpPr>
         <p:sp>
@@ -22053,7 +22893,7 @@
           <p:spPr>
             <a:xfrm>
               <a:off x="675894" y="1370648"/>
-              <a:ext cx="9467660" cy="743331"/>
+              <a:ext cx="9881235" cy="743331"/>
             </a:xfrm>
             <a:prstGeom prst="rect">
               <a:avLst/>
@@ -22081,7 +22921,7 @@
                   <a:ea typeface="Microsoft YaHei"/>
                   <a:cs typeface="Segoe UI"/>
                 </a:rPr>
-                <a:t>唯一输入是 Ba–Y–Zn–Si–O 硅酸盐的相图、合成与亚稳相问题；系统在直接证据稀疏时</a:t>
+                <a:t>唯一输入是一行主题“Ba5Y12Zn[O(SiO4)]8 及其结构相近化合物的合成条件”；</a:t>
               </a:r>
               <a:r>
                 <a:rPr lang="zh-CN" sz="1950" dirty="0">
@@ -22092,7 +22932,7 @@
                   <a:ea typeface="Microsoft YaHei"/>
                   <a:cs typeface="Segoe UI"/>
                 </a:rPr>
-                <a:t xml:space="preserve">仍完成 </a:t>
+                <a:t xml:space="preserve">在需要人确认的节点续跑后交出 20 页综述，再按材料专家 8 条意见修订为 </a:t>
               </a:r>
               <a:r>
                 <a:rPr lang="zh-CN" sz="1950" b="1" dirty="0">
@@ -22103,7 +22943,7 @@
                   <a:ea typeface="Microsoft YaHei"/>
                   <a:cs typeface="Segoe UI"/>
                 </a:rPr>
-                <a:t>35 页终稿</a:t>
+                <a:t>23 页正式稿</a:t>
               </a:r>
               <a:r>
                 <a:rPr lang="zh-CN" sz="1950" dirty="0">
@@ -22114,7 +22954,7 @@
                   <a:ea typeface="Microsoft YaHei"/>
                   <a:cs typeface="Segoe UI"/>
                 </a:rPr>
-                <a:t>，并把近邻证据、动力学边界与模型候选分层呈现。</a:t>
+                <a:t>。</a:t>
               </a:r>
             </a:p>
           </p:txBody>
@@ -22186,8 +23026,8 @@
           </p:nvSpPr>
           <p:spPr>
             <a:xfrm>
-              <a:off x="858012" y="2468880"/>
-              <a:ext cx="2301019" cy="704088"/>
+              <a:off x="857250" y="2404110"/>
+              <a:ext cx="2026909" cy="819150"/>
             </a:xfrm>
             <a:prstGeom prst="rect">
               <a:avLst/>
@@ -22205,7 +23045,7 @@
             <a:p>
               <a:pPr algn="l"/>
               <a:r>
-                <a:rPr lang="en-US" sz="3600" b="1" dirty="0">
+                <a:rPr lang="en-US" sz="4200" b="1" dirty="0">
                   <a:solidFill>
                     <a:schemeClr val="accent1"/>
                   </a:solidFill>
@@ -22213,7 +23053,7 @@
                   <a:ea typeface="Segoe UI"/>
                   <a:cs typeface="Segoe UI"/>
                 </a:rPr>
-                <a:t>513 / 513</a:t>
+                <a:t>51 / 51</a:t>
               </a:r>
             </a:p>
           </p:txBody>
@@ -22253,7 +23093,7 @@
                   <a:ea typeface="Microsoft YaHei"/>
                   <a:cs typeface="Segoe UI"/>
                 </a:rPr>
-                <a:t>引用记录逐条核对通过</a:t>
+                <a:t>参考文献逐条核对通过</a:t>
               </a:r>
             </a:p>
           </p:txBody>
@@ -22352,7 +23192,7 @@
                   <a:ea typeface="Segoe UI"/>
                   <a:cs typeface="Segoe UI"/>
                 </a:rPr>
-                <a:t>757</a:t>
+                <a:t>219</a:t>
               </a:r>
             </a:p>
           </p:txBody>
@@ -22366,7 +23206,7 @@
           <p:spPr>
             <a:xfrm>
               <a:off x="3612642" y="3016568"/>
-              <a:ext cx="2140039" cy="264033"/>
+              <a:ext cx="1776565" cy="264033"/>
             </a:xfrm>
             <a:prstGeom prst="rect">
               <a:avLst/>
@@ -22392,7 +23232,7 @@
                   <a:ea typeface="Microsoft YaHei"/>
                   <a:cs typeface="Segoe UI"/>
                 </a:rPr>
-                <a:t>次正文引用，整合率 100%</a:t>
+                <a:t>次引用，整合率 100%</a:t>
               </a:r>
             </a:p>
           </p:txBody>
@@ -22465,7 +23305,7 @@
           <p:spPr>
             <a:xfrm>
               <a:off x="6343650" y="2404110"/>
-              <a:ext cx="1373867" cy="819150"/>
+              <a:ext cx="1136397" cy="819150"/>
             </a:xfrm>
             <a:prstGeom prst="rect">
               <a:avLst/>
@@ -22483,15 +23323,15 @@
             <a:p>
               <a:pPr algn="l"/>
               <a:r>
-                <a:rPr lang="en-US" sz="4200" b="1" dirty="0">
+                <a:rPr lang="zh-CN" sz="4200" b="1" dirty="0">
                   <a:solidFill>
                     <a:schemeClr val="accent1"/>
                   </a:solidFill>
                   <a:latin typeface="Segoe UI"/>
-                  <a:ea typeface="Segoe UI"/>
-                  <a:cs typeface="Segoe UI"/>
-                </a:rPr>
-                <a:t>3 + 3</a:t>
+                  <a:ea typeface="Microsoft YaHei"/>
+                  <a:cs typeface="Segoe UI"/>
+                </a:rPr>
+                <a:t>3 张</a:t>
               </a:r>
             </a:p>
           </p:txBody>
@@ -22505,7 +23345,7 @@
           <p:spPr>
             <a:xfrm>
               <a:off x="6355842" y="3016568"/>
-              <a:ext cx="2221821" cy="264033"/>
+              <a:ext cx="1812912" cy="264033"/>
             </a:xfrm>
             <a:prstGeom prst="rect">
               <a:avLst/>
@@ -22531,7 +23371,7 @@
                   <a:ea typeface="Microsoft YaHei"/>
                   <a:cs typeface="Segoe UI"/>
                 </a:rPr>
-                <a:t>可编辑图 · 可检验实验设计</a:t>
+                <a:t>figspec 同源可编辑图</a:t>
               </a:r>
             </a:p>
           </p:txBody>
@@ -22604,7 +23444,7 @@
           <p:spPr>
             <a:xfrm>
               <a:off x="9086850" y="2404110"/>
-              <a:ext cx="1373867" cy="819150"/>
+              <a:ext cx="364621" cy="819150"/>
             </a:xfrm>
             <a:prstGeom prst="rect">
               <a:avLst/>
@@ -22630,7 +23470,7 @@
                   <a:ea typeface="Segoe UI"/>
                   <a:cs typeface="Segoe UI"/>
                 </a:rPr>
-                <a:t>0 / 0</a:t>
+                <a:t>0</a:t>
               </a:r>
             </a:p>
           </p:txBody>
@@ -22644,7 +23484,7 @@
           <p:spPr>
             <a:xfrm>
               <a:off x="9099042" y="3016568"/>
-              <a:ext cx="1785652" cy="264033"/>
+              <a:ext cx="2394471" cy="264033"/>
             </a:xfrm>
             <a:prstGeom prst="rect">
               <a:avLst/>
@@ -22670,7 +23510,7 @@
                   <a:ea typeface="Microsoft YaHei"/>
                   <a:cs typeface="Segoe UI"/>
                 </a:rPr>
-                <a:t>终审 blocker / major</a:t>
+                <a:t>两轮对抗审稿的终审 issue 数</a:t>
               </a:r>
             </a:p>
           </p:txBody>
@@ -22730,8 +23570,8 @@
           </p:blipFill>
           <p:spPr>
             <a:xfrm>
-              <a:off x="830263" y="3581400"/>
-              <a:ext cx="4254500" cy="2552700"/>
+              <a:off x="688446" y="3581400"/>
+              <a:ext cx="4538133" cy="2552700"/>
             </a:xfrm>
             <a:prstGeom prst="rect">
               <a:avLst/>
@@ -22747,10 +23587,10 @@
         </p:nvGrpSpPr>
         <p:grpSpPr>
           <a:xfrm>
-            <a:off x="679704" y="3653790"/>
-            <a:ext cx="10105644" cy="2795016"/>
-            <a:chOff x="679704" y="3653790"/>
-            <a:chExt cx="10105644" cy="2795016"/>
+            <a:off x="5591556" y="3653790"/>
+            <a:ext cx="5305234" cy="2484311"/>
+            <a:chOff x="5591556" y="3653790"/>
+            <a:chExt cx="5305234" cy="2484311"/>
           </a:xfrm>
         </p:grpSpPr>
         <p:sp>
@@ -22802,7 +23642,7 @@
           <p:spPr>
             <a:xfrm>
               <a:off x="5593842" y="4064318"/>
-              <a:ext cx="5191506" cy="1654683"/>
+              <a:ext cx="5302948" cy="1654683"/>
             </a:xfrm>
             <a:prstGeom prst="rect">
               <a:avLst/>
@@ -22836,7 +23676,7 @@
                   <a:ea typeface="Microsoft YaHei"/>
                   <a:cs typeface="Segoe UI"/>
                 </a:rPr>
-                <a:t>15 批 / 24 个任务轨迹，42 次工具调用；输入、异常与审稿均留痕</a:t>
+                <a:t>顶层编排器 5 次调用（首轮 + 4 次续跑），29 批 / 40 个子任务</a:t>
               </a:r>
             </a:p>
             <a:p>
@@ -22863,7 +23703,7 @@
                   <a:ea typeface="Microsoft YaHei"/>
                   <a:cs typeface="Segoe UI"/>
                 </a:rPr>
-                <a:t>516 条检索记录 → 513 条去重文献；七个子主题无关键词缺口</a:t>
+                <a:t>63 条候选 → 51 篇入库；5 条作者名不匹配经人确认后删除</a:t>
               </a:r>
             </a:p>
             <a:p>
@@ -22890,7 +23730,7 @@
                   <a:ea typeface="Microsoft YaHei"/>
                   <a:cs typeface="Segoe UI"/>
                 </a:rPr>
-                <a:t>三个方向：相纯窗口、亚稳态热历史、带盲测的闭环相图设计</a:t>
+                <a:t>两轮对抗审稿：首轮 7 项 issue 路由返工，第二轮 0 / 0 / 0</a:t>
               </a:r>
             </a:p>
             <a:p>
@@ -22917,7 +23757,7 @@
                   <a:ea typeface="Microsoft YaHei"/>
                   <a:cs typeface="Segoe UI"/>
                 </a:rPr>
-                <a:t>三图均保留 figspec / SVG / draw.io 同源可编辑版本</a:t>
+                <a:t>正式报告调用前驱体预测 3 次（Zn / Mg / Co 目标）</a:t>
               </a:r>
             </a:p>
             <a:p>
@@ -22944,21 +23784,8 @@
                   <a:ea typeface="Microsoft YaHei"/>
                   <a:cs typeface="Segoe UI"/>
                 </a:rPr>
-                <a:t>格式终审 0 blocker / 0 major；仅 1 个参考文献元数据 minor</a:t>
-              </a:r>
-            </a:p>
-            <a:p>
-              <a:pPr algn="l" marL="145732" indent="-145732">
-                <a:lnSpc>
-                  <a:spcPts val="1950"/>
-                </a:lnSpc>
-                <a:buClr>
-                  <a:schemeClr val="dk1"/>
-                </a:buClr>
-                <a:buSzTx/>
-                <a:buFontTx/>
-                <a:buChar char="•"/>
-              </a:pPr>
+                <a:t>专家反馈修订：正规论文语言、同类体系单独成节、前人结论汇总、</a:t>
+              </a:r>
               <a:r>
                 <a:rPr lang="zh-CN" sz="1350" dirty="0">
                   <a:solidFill>
@@ -22968,7 +23795,7 @@
                   <a:ea typeface="Microsoft YaHei"/>
                   <a:cs typeface="Segoe UI"/>
                 </a:rPr>
-                <a:t>边界：未见可复现相纯四元晶相；模型候选不是实验事实</a:t>
+                <a:t>方向落到工艺与前驱体、相图讨论、学术排版图、去除工程术语</a:t>
               </a:r>
             </a:p>
           </p:txBody>
@@ -22981,8 +23808,8 @@
           </p:nvSpPr>
           <p:spPr>
             <a:xfrm>
-              <a:off x="679704" y="6214110"/>
-              <a:ext cx="3549720" cy="234696"/>
+              <a:off x="5593842" y="5874068"/>
+              <a:ext cx="4011930" cy="264033"/>
             </a:xfrm>
             <a:prstGeom prst="rect">
               <a:avLst/>
@@ -23000,7 +23827,7 @@
             <a:p>
               <a:pPr algn="l"/>
               <a:r>
-                <a:rPr lang="zh-CN" sz="1200" dirty="0">
+                <a:rPr lang="zh-CN" sz="1350" dirty="0">
                   <a:solidFill>
                     <a:schemeClr val="dk2"/>
                   </a:solidFill>
@@ -23008,7 +23835,7 @@
                   <a:ea typeface="Microsoft YaHei"/>
                   <a:cs typeface="Segoe UI"/>
                 </a:rPr>
-                <a:t>左图：最新终稿中的 Ba–Y–Zn–Si–O 证据分类图</a:t>
+                <a:t>左图：正式报告研究路线图（第三轮学术化重绘）</a:t>
               </a:r>
             </a:p>
           </p:txBody>
@@ -23154,9 +23981,9 @@
         <p:grpSpPr>
           <a:xfrm>
             <a:off x="670560" y="590550"/>
-            <a:ext cx="10271360" cy="586740"/>
+            <a:ext cx="11479911" cy="586740"/>
             <a:chOff x="670560" y="590550"/>
-            <a:chExt cx="10271360" cy="586740"/>
+            <a:chExt cx="11479911" cy="586740"/>
           </a:xfrm>
         </p:grpSpPr>
         <p:sp>
@@ -23168,7 +23995,7 @@
           <p:spPr>
             <a:xfrm>
               <a:off x="670560" y="590550"/>
-              <a:ext cx="10271360" cy="586740"/>
+              <a:ext cx="11479911" cy="586740"/>
             </a:xfrm>
             <a:prstGeom prst="rect">
               <a:avLst/>
@@ -23194,7 +24021,7 @@
                   <a:ea typeface="Microsoft YaHei"/>
                   <a:cs typeface="Segoe UI"/>
                 </a:rPr>
-                <a:t>缺的不是单一配方，而是四元相图与平衡 / 亚稳态判据</a:t>
+                <a:t>目标相只有一篇直接报道；组成坐标比单一温度更能解释成相</a:t>
               </a:r>
             </a:p>
           </p:txBody>
@@ -23231,9 +24058,9 @@
         <p:grpSpPr>
           <a:xfrm>
             <a:off x="675894" y="1370648"/>
-            <a:ext cx="8826989" cy="381381"/>
+            <a:ext cx="9640767" cy="381381"/>
             <a:chOff x="675894" y="1370648"/>
-            <a:chExt cx="8826989" cy="381381"/>
+            <a:chExt cx="9640767" cy="381381"/>
           </a:xfrm>
         </p:grpSpPr>
         <p:sp>
@@ -23245,7 +24072,7 @@
           <p:spPr>
             <a:xfrm>
               <a:off x="675894" y="1370648"/>
-              <a:ext cx="8826989" cy="381381"/>
+              <a:ext cx="9640767" cy="381381"/>
             </a:xfrm>
             <a:prstGeom prst="rect">
               <a:avLst/>
@@ -23271,7 +24098,7 @@
                   <a:ea typeface="Microsoft YaHei"/>
                   <a:cs typeface="Segoe UI"/>
                 </a:rPr>
-                <a:t>系统把“已报道事实—近邻类比—模型候选”分开，给出三个</a:t>
+                <a:t>系统给出的不是配方，而是文献证据限定的</a:t>
               </a:r>
               <a:r>
                 <a:rPr lang="zh-CN" sz="1950" b="1" dirty="0">
@@ -23282,7 +24109,29 @@
                   <a:ea typeface="Microsoft YaHei"/>
                   <a:cs typeface="Segoe UI"/>
                 </a:rPr>
-                <a:t>可证伪实验方向</a:t>
+                <a:t>可迁移范围</a:t>
+              </a:r>
+              <a:r>
+                <a:rPr lang="zh-CN" sz="1950" dirty="0">
+                  <a:solidFill>
+                    <a:schemeClr val="dk1"/>
+                  </a:solidFill>
+                  <a:latin typeface="Segoe UI"/>
+                  <a:ea typeface="Microsoft YaHei"/>
+                  <a:cs typeface="Segoe UI"/>
+                </a:rPr>
+                <a:t>与四类</a:t>
+              </a:r>
+              <a:r>
+                <a:rPr lang="zh-CN" sz="1950" b="1" dirty="0">
+                  <a:solidFill>
+                    <a:schemeClr val="accent2"/>
+                  </a:solidFill>
+                  <a:latin typeface="Segoe UI"/>
+                  <a:ea typeface="Microsoft YaHei"/>
+                  <a:cs typeface="Segoe UI"/>
+                </a:rPr>
+                <a:t>可检验的实验方向</a:t>
               </a:r>
               <a:r>
                 <a:rPr lang="zh-CN" sz="1950" dirty="0">
@@ -23301,16 +24150,16 @@
       </p:grpSp>
       <p:grpSp>
         <p:nvGrpSpPr>
-          <p:cNvPr id="17" name="Group 17"/>
+          <p:cNvPr id="16" name="Group 16"/>
           <p:cNvGrpSpPr/>
           <p:nvPr/>
         </p:nvGrpSpPr>
         <p:grpSpPr>
           <a:xfrm>
             <a:off x="676656" y="1920240"/>
-            <a:ext cx="5305044" cy="3798761"/>
+            <a:ext cx="5361432" cy="3551111"/>
             <a:chOff x="676656" y="1920240"/>
-            <a:chExt cx="5305044" cy="3798761"/>
+            <a:chExt cx="5361432" cy="3551111"/>
           </a:xfrm>
         </p:grpSpPr>
         <p:sp>
@@ -23402,7 +24251,7 @@
           <p:spPr>
             <a:xfrm>
               <a:off x="983742" y="2426018"/>
-              <a:ext cx="3777044" cy="721233"/>
+              <a:ext cx="5054346" cy="511683"/>
             </a:xfrm>
             <a:prstGeom prst="rect">
               <a:avLst/>
@@ -23418,7 +24267,7 @@
             <a:p>
               <a:pPr algn="l">
                 <a:lnSpc>
-                  <a:spcPts val="1800"/>
+                  <a:spcPts val="1950"/>
                 </a:lnSpc>
               </a:pPr>
               <a:r>
@@ -23430,7 +24279,7 @@
                   <a:ea typeface="Microsoft YaHei"/>
                   <a:cs typeface="Segoe UI"/>
                 </a:rPr>
-                <a:t>513 条核验文献仍未证明可复现的相纯四元晶相；</a:t>
+                <a:t>公开证据只能确认“开放体系高温溶液法 + 单晶 X 射线衍射鉴定”，</a:t>
               </a:r>
               <a:r>
                 <a:rPr lang="zh-CN" sz="1350" dirty="0">
@@ -23441,18 +24290,7 @@
                   <a:ea typeface="Microsoft YaHei"/>
                   <a:cs typeface="Segoe UI"/>
                 </a:rPr>
-                <a:t>邻近硅酸盐只支持结构、路线或热力学边界，</a:t>
-              </a:r>
-              <a:r>
-                <a:rPr lang="zh-CN" sz="1350" dirty="0">
-                  <a:solidFill>
-                    <a:schemeClr val="dk1"/>
-                  </a:solidFill>
-                  <a:latin typeface="Segoe UI"/>
-                  <a:ea typeface="Microsoft YaHei"/>
-                  <a:cs typeface="Segoe UI"/>
-                </a:rPr>
-                <a:t>不能替代 Ba–Y–Zn–Si–O 目标证据。</a:t>
+                <a:t>不足以给出经验证的目标相复现配方。</a:t>
               </a:r>
             </a:p>
           </p:txBody>
@@ -23465,7 +24303,7 @@
           </p:nvSpPr>
           <p:spPr>
             <a:xfrm>
-              <a:off x="676656" y="3291840"/>
+              <a:off x="676656" y="3044190"/>
               <a:ext cx="158225" cy="352044"/>
             </a:xfrm>
             <a:prstGeom prst="rect">
@@ -23505,8 +24343,8 @@
           </p:nvSpPr>
           <p:spPr>
             <a:xfrm>
-              <a:off x="983742" y="3340418"/>
-              <a:ext cx="3982783" cy="721233"/>
+              <a:off x="983742" y="3092768"/>
+              <a:ext cx="4917186" cy="759333"/>
             </a:xfrm>
             <a:prstGeom prst="rect">
               <a:avLst/>
@@ -23522,7 +24360,7 @@
             <a:p>
               <a:pPr algn="l">
                 <a:lnSpc>
-                  <a:spcPts val="1800"/>
+                  <a:spcPts val="1950"/>
                 </a:lnSpc>
               </a:pPr>
               <a:r>
@@ -23534,7 +24372,7 @@
                   <a:ea typeface="Microsoft YaHei"/>
                   <a:cs typeface="Segoe UI"/>
                 </a:rPr>
-                <a:t>可比较记录须保留实际组成、前驱体、坩埚 / 气氛、</a:t>
+                <a:t>无 Zn 谱系提供三类可比路线：MoO3 助熔（Pt 坩埚、1150 °C、</a:t>
               </a:r>
               <a:r>
                 <a:rPr lang="zh-CN" sz="1350" dirty="0">
@@ -23545,7 +24383,7 @@
                   <a:ea typeface="Microsoft YaHei"/>
                   <a:cs typeface="Segoe UI"/>
                 </a:rPr>
-                <a:t>升降温与淬冷历史、相组成和不确定性；</a:t>
+                <a:t>2 K/h）、x:26:16 固相陶瓷（1300 / 1600 °C）、5:13:8 粉体</a:t>
               </a:r>
               <a:r>
                 <a:rPr lang="zh-CN" sz="1350" dirty="0">
@@ -23556,7 +24394,29 @@
                   <a:ea typeface="Microsoft YaHei"/>
                   <a:cs typeface="Segoe UI"/>
                 </a:rPr>
-                <a:t>字段不全时不做“最佳路线”排名。</a:t>
+                <a:t>相场筛查（1273 / 1573 K）；</a:t>
+              </a:r>
+              <a:r>
+                <a:rPr lang="zh-CN" sz="1350" b="1" dirty="0">
+                  <a:solidFill>
+                    <a:schemeClr val="dk1"/>
+                  </a:solidFill>
+                  <a:latin typeface="Segoe UI"/>
+                  <a:ea typeface="Microsoft YaHei"/>
+                  <a:cs typeface="Segoe UI"/>
+                </a:rPr>
+                <a:t>具体数值不得无条件迁移</a:t>
+              </a:r>
+              <a:r>
+                <a:rPr lang="zh-CN" sz="1350" dirty="0">
+                  <a:solidFill>
+                    <a:schemeClr val="dk1"/>
+                  </a:solidFill>
+                  <a:latin typeface="Segoe UI"/>
+                  <a:ea typeface="Microsoft YaHei"/>
+                  <a:cs typeface="Segoe UI"/>
+                </a:rPr>
+                <a:t>。</a:t>
               </a:r>
             </a:p>
           </p:txBody>
@@ -23569,7 +24429,7 @@
           </p:nvSpPr>
           <p:spPr>
             <a:xfrm>
-              <a:off x="676656" y="4206240"/>
+              <a:off x="676656" y="3958590"/>
               <a:ext cx="158225" cy="352044"/>
             </a:xfrm>
             <a:prstGeom prst="rect">
@@ -23609,24 +24469,26 @@
           </p:nvSpPr>
           <p:spPr>
             <a:xfrm>
-              <a:off x="983742" y="4254818"/>
-              <a:ext cx="3345332" cy="264033"/>
-            </a:xfrm>
-            <a:prstGeom prst="rect">
-              <a:avLst/>
-            </a:prstGeom>
-            <a:noFill/>
-            <a:ln>
-              <a:noFill/>
-            </a:ln>
-          </p:spPr>
-          <p:txBody>
-            <a:bodyPr wrap="none" lIns="0" tIns="0" rIns="0" bIns="0" anchor="t" anchorCtr="0">
-              <a:spAutoFit/>
-            </a:bodyPr>
-            <a:lstStyle/>
-            <a:p>
-              <a:pPr algn="l"/>
+              <a:off x="983742" y="4007168"/>
+              <a:ext cx="3477006" cy="511683"/>
+            </a:xfrm>
+            <a:prstGeom prst="rect">
+              <a:avLst/>
+            </a:prstGeom>
+            <a:noFill/>
+            <a:ln>
+              <a:noFill/>
+            </a:ln>
+          </p:spPr>
+          <p:txBody>
+            <a:bodyPr wrap="square" lIns="0" tIns="0" rIns="0" bIns="0" anchor="t" anchorCtr="0"/>
+            <a:lstStyle/>
+            <a:p>
+              <a:pPr algn="l">
+                <a:lnSpc>
+                  <a:spcPts val="1950"/>
+                </a:lnSpc>
+              </a:pPr>
               <a:r>
                 <a:rPr lang="zh-CN" sz="1350" dirty="0">
                   <a:solidFill>
@@ -23636,37 +24498,8 @@
                   <a:ea typeface="Microsoft YaHei"/>
                   <a:cs typeface="Segoe UI"/>
                 </a:rPr>
-                <a:t>XRD、EPMA / WDS 与热历史联合判读；</a:t>
-              </a:r>
-            </a:p>
-          </p:txBody>
-        </p:sp>
-        <p:sp>
-          <p:nvSpPr>
-            <p:cNvPr id="14" name="TextBox 14"/>
-            <p:cNvSpPr txBox="1"/>
-            <p:nvPr/>
-          </p:nvSpPr>
-          <p:spPr>
-            <a:xfrm>
-              <a:off x="983742" y="4483418"/>
-              <a:ext cx="3484893" cy="264033"/>
-            </a:xfrm>
-            <a:prstGeom prst="rect">
-              <a:avLst/>
-            </a:prstGeom>
-            <a:noFill/>
-            <a:ln>
-              <a:noFill/>
-            </a:ln>
-          </p:spPr>
-          <p:txBody>
-            <a:bodyPr wrap="none" lIns="0" tIns="0" rIns="0" bIns="0" anchor="t" anchorCtr="0">
-              <a:spAutoFit/>
-            </a:bodyPr>
-            <a:lstStyle/>
-            <a:p>
-              <a:pPr algn="l"/>
+                <a:t>“获得单晶”不等于“建立批量相纯窗口”；</a:t>
+              </a:r>
               <a:r>
                 <a:rPr lang="zh-CN" sz="1350" b="1" dirty="0">
                   <a:solidFill>
@@ -23676,7 +24509,7 @@
                   <a:ea typeface="Microsoft YaHei"/>
                   <a:cs typeface="Segoe UI"/>
                 </a:rPr>
-                <a:t>相纯</a:t>
+                <a:t>局部相图</a:t>
               </a:r>
               <a:r>
                 <a:rPr lang="zh-CN" sz="1350" dirty="0">
@@ -23687,20 +24520,20 @@
                   <a:ea typeface="Microsoft YaHei"/>
                   <a:cs typeface="Segoe UI"/>
                 </a:rPr>
-                <a:t>、组成漂移与动力学滞留须分别判定。</a:t>
-              </a:r>
-            </a:p>
-          </p:txBody>
-        </p:sp>
-        <p:sp>
-          <p:nvSpPr>
-            <p:cNvPr id="15" name="Line 15"/>
+                <a:t>是连接复现与科学发现的核心实验。</a:t>
+              </a:r>
+            </a:p>
+          </p:txBody>
+        </p:sp>
+        <p:sp>
+          <p:nvSpPr>
+            <p:cNvPr id="14" name="Line 14"/>
             <p:cNvSpPr/>
             <p:nvPr/>
           </p:nvSpPr>
           <p:spPr>
             <a:xfrm>
-              <a:off x="685800" y="5048250"/>
+              <a:off x="685800" y="4762500"/>
               <a:ext cx="5295900" cy="9525"/>
             </a:xfrm>
             <a:custGeom>
@@ -23730,14 +24563,14 @@
         </p:sp>
         <p:sp>
           <p:nvSpPr>
-            <p:cNvPr id="16" name="TextBox 16"/>
-            <p:cNvSpPr txBox="1"/>
-            <p:nvPr/>
-          </p:nvSpPr>
-          <p:spPr>
-            <a:xfrm>
-              <a:off x="678942" y="5226368"/>
-              <a:ext cx="3614166" cy="492633"/>
+            <p:cNvPr id="15" name="TextBox 15"/>
+            <p:cNvSpPr txBox="1"/>
+            <p:nvPr/>
+          </p:nvSpPr>
+          <p:spPr>
+            <a:xfrm>
+              <a:off x="678942" y="4959668"/>
+              <a:ext cx="3991356" cy="511683"/>
             </a:xfrm>
             <a:prstGeom prst="rect">
               <a:avLst/>
@@ -23753,7 +24586,7 @@
             <a:p>
               <a:pPr algn="l">
                 <a:lnSpc>
-                  <a:spcPts val="1800"/>
+                  <a:spcPts val="1950"/>
                 </a:lnSpc>
               </a:pPr>
               <a:r>
@@ -23765,7 +24598,7 @@
                   <a:ea typeface="Microsoft YaHei"/>
                   <a:cs typeface="Segoe UI"/>
                 </a:rPr>
-                <a:t>直接证据不足时明确降级，不把综述覆盖度、</a:t>
+                <a:t>合成条件表逐字段区分“原文可支持”与“不可支持”，</a:t>
               </a:r>
               <a:r>
                 <a:rPr lang="zh-CN" sz="1350" dirty="0">
@@ -23776,7 +24609,7 @@
                   <a:ea typeface="Microsoft YaHei"/>
                   <a:cs typeface="Segoe UI"/>
                 </a:rPr>
-                <a:t>模型置信度或邻近成功误写成目标相已经合成。</a:t>
+                <a:t>36 条结论带原文页码定位</a:t>
               </a:r>
             </a:p>
           </p:txBody>
@@ -23784,21 +24617,21 @@
       </p:grpSp>
       <p:grpSp>
         <p:nvGrpSpPr>
-          <p:cNvPr id="31" name="Group 31"/>
+          <p:cNvPr id="29" name="Group 29"/>
           <p:cNvGrpSpPr/>
           <p:nvPr/>
         </p:nvGrpSpPr>
         <p:grpSpPr>
           <a:xfrm>
             <a:off x="6210300" y="1905000"/>
-            <a:ext cx="5295900" cy="4229100"/>
+            <a:ext cx="5311750" cy="4233101"/>
             <a:chOff x="6210300" y="1905000"/>
-            <a:chExt cx="5295900" cy="4229100"/>
+            <a:chExt cx="5311750" cy="4233101"/>
           </a:xfrm>
         </p:grpSpPr>
         <p:sp>
           <p:nvSpPr>
-            <p:cNvPr id="18" name="Rectangle 18"/>
+            <p:cNvPr id="17" name="Rectangle 17"/>
             <p:cNvSpPr/>
             <p:nvPr/>
           </p:nvSpPr>
@@ -23820,14 +24653,14 @@
         </p:sp>
         <p:sp>
           <p:nvSpPr>
-            <p:cNvPr id="19" name="TextBox 19"/>
+            <p:cNvPr id="18" name="TextBox 18"/>
             <p:cNvSpPr txBox="1"/>
             <p:nvPr/>
           </p:nvSpPr>
           <p:spPr>
             <a:xfrm>
               <a:off x="6429756" y="2053590"/>
-              <a:ext cx="3580333" cy="352044"/>
+              <a:ext cx="4852492" cy="352044"/>
             </a:xfrm>
             <a:prstGeom prst="rect">
               <a:avLst/>
@@ -23853,21 +24686,21 @@
                   <a:ea typeface="Microsoft YaHei"/>
                   <a:cs typeface="Segoe UI"/>
                 </a:rPr>
-                <a:t>三个优先实验（各有失败判据）</a:t>
-              </a:r>
-            </a:p>
-          </p:txBody>
-        </p:sp>
-        <p:sp>
-          <p:nvSpPr>
-            <p:cNvPr id="20" name="TextBox 20"/>
+                <a:t>四个值得探索的方向（各配工艺与前驱体）</a:t>
+              </a:r>
+            </a:p>
+          </p:txBody>
+        </p:sp>
+        <p:sp>
+          <p:nvSpPr>
+            <p:cNvPr id="19" name="TextBox 19"/>
             <p:cNvSpPr txBox="1"/>
             <p:nvPr/>
           </p:nvSpPr>
           <p:spPr>
             <a:xfrm>
               <a:off x="6429756" y="2491740"/>
-              <a:ext cx="3138712" cy="352044"/>
+              <a:ext cx="2896396" cy="352044"/>
             </a:xfrm>
             <a:prstGeom prst="rect">
               <a:avLst/>
@@ -23904,21 +24737,21 @@
                   <a:ea typeface="Microsoft YaHei"/>
                   <a:cs typeface="Segoe UI"/>
                 </a:rPr>
-                <a:t xml:space="preserve"> 测量缺失的四元相图子空间</a:t>
-              </a:r>
-            </a:p>
-          </p:txBody>
-        </p:sp>
-        <p:sp>
-          <p:nvSpPr>
-            <p:cNvPr id="21" name="TextBox 21"/>
+                <a:t xml:space="preserve"> 目标组成附近的局部相图</a:t>
+              </a:r>
+            </a:p>
+          </p:txBody>
+        </p:sp>
+        <p:sp>
+          <p:nvSpPr>
+            <p:cNvPr id="20" name="TextBox 20"/>
             <p:cNvSpPr txBox="1"/>
             <p:nvPr/>
           </p:nvSpPr>
           <p:spPr>
             <a:xfrm>
               <a:off x="6774942" y="2807018"/>
-              <a:ext cx="2249081" cy="264033"/>
+              <a:ext cx="4106227" cy="264033"/>
             </a:xfrm>
             <a:prstGeom prst="rect">
               <a:avLst/>
@@ -23944,21 +24777,21 @@
                   <a:ea typeface="Microsoft YaHei"/>
                   <a:cs typeface="Segoe UI"/>
                 </a:rPr>
-                <a:t>组成网格 + 平衡 / 淬冷配对</a:t>
-              </a:r>
-            </a:p>
-          </p:txBody>
-        </p:sp>
-        <p:sp>
-          <p:nvSpPr>
-            <p:cNvPr id="22" name="TextBox 22"/>
-            <p:cNvSpPr txBox="1"/>
-            <p:nvPr/>
-          </p:nvSpPr>
-          <p:spPr>
-            <a:xfrm>
-              <a:off x="6774942" y="3016568"/>
-              <a:ext cx="2500427" cy="264033"/>
+                <a:t>固相成相组成系列 + 定量 PXRD / Rietveld 相分数</a:t>
+              </a:r>
+            </a:p>
+          </p:txBody>
+        </p:sp>
+        <p:sp>
+          <p:nvSpPr>
+            <p:cNvPr id="21" name="TextBox 21"/>
+            <p:cNvSpPr txBox="1"/>
+            <p:nvPr/>
+          </p:nvSpPr>
+          <p:spPr>
+            <a:xfrm>
+              <a:off x="6429756" y="3158490"/>
+              <a:ext cx="2187759" cy="352044"/>
             </a:xfrm>
             <a:prstGeom prst="rect">
               <a:avLst/>
@@ -23976,29 +24809,40 @@
             <a:p>
               <a:pPr algn="l"/>
               <a:r>
-                <a:rPr lang="zh-CN" sz="1350" dirty="0">
-                  <a:solidFill>
-                    <a:schemeClr val="dk2"/>
-                  </a:solidFill>
-                  <a:latin typeface="Segoe UI"/>
-                  <a:ea typeface="Microsoft YaHei"/>
-                  <a:cs typeface="Segoe UI"/>
-                </a:rPr>
-                <a:t>XRD 与 EPMA / WDS 联合判定</a:t>
-              </a:r>
-            </a:p>
-          </p:txBody>
-        </p:sp>
-        <p:sp>
-          <p:nvSpPr>
-            <p:cNvPr id="23" name="TextBox 23"/>
-            <p:cNvSpPr txBox="1"/>
-            <p:nvPr/>
-          </p:nvSpPr>
-          <p:spPr>
-            <a:xfrm>
-              <a:off x="6429756" y="3348990"/>
-              <a:ext cx="2654080" cy="352044"/>
+                <a:rPr lang="en-US" sz="1800" b="1" dirty="0">
+                  <a:solidFill>
+                    <a:schemeClr val="accent2"/>
+                  </a:solidFill>
+                  <a:latin typeface="Segoe UI"/>
+                  <a:ea typeface="Segoe UI"/>
+                  <a:cs typeface="Segoe UI"/>
+                </a:rPr>
+                <a:t>②</a:t>
+              </a:r>
+              <a:r>
+                <a:rPr lang="zh-CN" sz="1800" dirty="0">
+                  <a:solidFill>
+                    <a:schemeClr val="dk1"/>
+                  </a:solidFill>
+                  <a:latin typeface="Segoe UI"/>
+                  <a:ea typeface="Microsoft YaHei"/>
+                  <a:cs typeface="Segoe UI"/>
+                </a:rPr>
+                <a:t xml:space="preserve"> Zn–Y–氧计量耦合</a:t>
+              </a:r>
+            </a:p>
+          </p:txBody>
+        </p:sp>
+        <p:sp>
+          <p:nvSpPr>
+            <p:cNvPr id="22" name="TextBox 22"/>
+            <p:cNvSpPr txBox="1"/>
+            <p:nvPr/>
+          </p:nvSpPr>
+          <p:spPr>
+            <a:xfrm>
+              <a:off x="6774942" y="3473768"/>
+              <a:ext cx="4747108" cy="264033"/>
             </a:xfrm>
             <a:prstGeom prst="rect">
               <a:avLst/>
@@ -24016,40 +24860,29 @@
             <a:p>
               <a:pPr algn="l"/>
               <a:r>
-                <a:rPr lang="en-US" sz="1800" b="1" dirty="0">
-                  <a:solidFill>
-                    <a:schemeClr val="accent2"/>
-                  </a:solidFill>
-                  <a:latin typeface="Segoe UI"/>
-                  <a:ea typeface="Segoe UI"/>
-                  <a:cs typeface="Segoe UI"/>
-                </a:rPr>
-                <a:t>②</a:t>
-              </a:r>
-              <a:r>
-                <a:rPr lang="zh-CN" sz="1800" dirty="0">
-                  <a:solidFill>
-                    <a:schemeClr val="dk1"/>
-                  </a:solidFill>
-                  <a:latin typeface="Segoe UI"/>
-                  <a:ea typeface="Microsoft YaHei"/>
-                  <a:cs typeface="Segoe UI"/>
-                </a:rPr>
-                <a:t xml:space="preserve"> 区分亚稳态与组成漂移</a:t>
-              </a:r>
-            </a:p>
-          </p:txBody>
-        </p:sp>
-        <p:sp>
-          <p:nvSpPr>
-            <p:cNvPr id="24" name="TextBox 24"/>
-            <p:cNvSpPr txBox="1"/>
-            <p:nvPr/>
-          </p:nvSpPr>
-          <p:spPr>
-            <a:xfrm>
-              <a:off x="6774942" y="3664268"/>
-              <a:ext cx="2030997" cy="264033"/>
+                <a:rPr lang="zh-CN" sz="1350" dirty="0">
+                  <a:solidFill>
+                    <a:schemeClr val="dk2"/>
+                  </a:solidFill>
+                  <a:latin typeface="Segoe UI"/>
+                  <a:ea typeface="Microsoft YaHei"/>
+                  <a:cs typeface="Segoe UI"/>
+                </a:rPr>
+                <a:t>名义 / 实际化学计量对照，EDS / EPMA 与结构模型互证</a:t>
+              </a:r>
+            </a:p>
+          </p:txBody>
+        </p:sp>
+        <p:sp>
+          <p:nvSpPr>
+            <p:cNvPr id="23" name="TextBox 23"/>
+            <p:cNvSpPr txBox="1"/>
+            <p:nvPr/>
+          </p:nvSpPr>
+          <p:spPr>
+            <a:xfrm>
+              <a:off x="6429756" y="3825240"/>
+              <a:ext cx="3381028" cy="352044"/>
             </a:xfrm>
             <a:prstGeom prst="rect">
               <a:avLst/>
@@ -24067,29 +24900,40 @@
             <a:p>
               <a:pPr algn="l"/>
               <a:r>
-                <a:rPr lang="zh-CN" sz="1350" dirty="0">
-                  <a:solidFill>
-                    <a:schemeClr val="dk2"/>
-                  </a:solidFill>
-                  <a:latin typeface="Segoe UI"/>
-                  <a:ea typeface="Microsoft YaHei"/>
-                  <a:cs typeface="Segoe UI"/>
-                </a:rPr>
-                <a:t>时间—温度—冷却路径矩阵</a:t>
-              </a:r>
-            </a:p>
-          </p:txBody>
-        </p:sp>
-        <p:sp>
-          <p:nvSpPr>
-            <p:cNvPr id="25" name="TextBox 25"/>
-            <p:cNvSpPr txBox="1"/>
-            <p:nvPr/>
-          </p:nvSpPr>
-          <p:spPr>
-            <a:xfrm>
-              <a:off x="6774942" y="3873818"/>
-              <a:ext cx="2760859" cy="264033"/>
+                <a:rPr lang="en-US" sz="1800" b="1" dirty="0">
+                  <a:solidFill>
+                    <a:schemeClr val="accent2"/>
+                  </a:solidFill>
+                  <a:latin typeface="Segoe UI"/>
+                  <a:ea typeface="Segoe UI"/>
+                  <a:cs typeface="Segoe UI"/>
+                </a:rPr>
+                <a:t>③</a:t>
+              </a:r>
+              <a:r>
+                <a:rPr lang="zh-CN" sz="1800" dirty="0">
+                  <a:solidFill>
+                    <a:schemeClr val="dk1"/>
+                  </a:solidFill>
+                  <a:latin typeface="Segoe UI"/>
+                  <a:ea typeface="Microsoft YaHei"/>
+                  <a:cs typeface="Segoe UI"/>
+                </a:rPr>
+                <a:t xml:space="preserve"> 固相成相与高温溶液长晶并行</a:t>
+              </a:r>
+            </a:p>
+          </p:txBody>
+        </p:sp>
+        <p:sp>
+          <p:nvSpPr>
+            <p:cNvPr id="24" name="TextBox 24"/>
+            <p:cNvSpPr txBox="1"/>
+            <p:nvPr/>
+          </p:nvSpPr>
+          <p:spPr>
+            <a:xfrm>
+              <a:off x="6774942" y="4140518"/>
+              <a:ext cx="3648456" cy="264033"/>
             </a:xfrm>
             <a:prstGeom prst="rect">
               <a:avLst/>
@@ -24115,21 +24959,21 @@
                   <a:ea typeface="Microsoft YaHei"/>
                   <a:cs typeface="Segoe UI"/>
                 </a:rPr>
-                <a:t>联测 Zn 损失、热分析与结构变化</a:t>
-              </a:r>
-            </a:p>
-          </p:txBody>
-        </p:sp>
-        <p:sp>
-          <p:nvSpPr>
-            <p:cNvPr id="26" name="TextBox 26"/>
-            <p:cNvSpPr txBox="1"/>
-            <p:nvPr/>
-          </p:nvSpPr>
-          <p:spPr>
-            <a:xfrm>
-              <a:off x="6429756" y="4206240"/>
-              <a:ext cx="2896396" cy="352044"/>
+                <a:t>单晶确认结构模型，批量样品测定目标相比例</a:t>
+              </a:r>
+            </a:p>
+          </p:txBody>
+        </p:sp>
+        <p:sp>
+          <p:nvSpPr>
+            <p:cNvPr id="25" name="TextBox 25"/>
+            <p:cNvSpPr txBox="1"/>
+            <p:nvPr/>
+          </p:nvSpPr>
+          <p:spPr>
+            <a:xfrm>
+              <a:off x="6429756" y="4491990"/>
+              <a:ext cx="3189650" cy="352044"/>
             </a:xfrm>
             <a:prstGeom prst="rect">
               <a:avLst/>
@@ -24155,7 +24999,7 @@
                   <a:ea typeface="Segoe UI"/>
                   <a:cs typeface="Segoe UI"/>
                 </a:rPr>
-                <a:t>③</a:t>
+                <a:t>④</a:t>
               </a:r>
               <a:r>
                 <a:rPr lang="zh-CN" sz="1800" dirty="0">
@@ -24166,21 +25010,21 @@
                   <a:ea typeface="Microsoft YaHei"/>
                   <a:cs typeface="Segoe UI"/>
                 </a:rPr>
-                <a:t xml:space="preserve"> 不确定性感知的闭环选点</a:t>
-              </a:r>
-            </a:p>
-          </p:txBody>
-        </p:sp>
-        <p:sp>
-          <p:nvSpPr>
-            <p:cNvPr id="27" name="TextBox 27"/>
-            <p:cNvSpPr txBox="1"/>
-            <p:nvPr/>
-          </p:nvSpPr>
-          <p:spPr>
-            <a:xfrm>
-              <a:off x="6774942" y="4521518"/>
-              <a:ext cx="2585295" cy="264033"/>
+                <a:t xml:space="preserve"> Mg / Co 类比与模型前驱体</a:t>
+              </a:r>
+            </a:p>
+          </p:txBody>
+        </p:sp>
+        <p:sp>
+          <p:nvSpPr>
+            <p:cNvPr id="26" name="TextBox 26"/>
+            <p:cNvSpPr txBox="1"/>
+            <p:nvPr/>
+          </p:nvSpPr>
+          <p:spPr>
+            <a:xfrm>
+              <a:off x="6774942" y="4807268"/>
+              <a:ext cx="3854110" cy="264033"/>
             </a:xfrm>
             <a:prstGeom prst="rect">
               <a:avLst/>
@@ -24206,54 +25050,14 @@
                   <a:ea typeface="Microsoft YaHei"/>
                   <a:cs typeface="Segoe UI"/>
                 </a:rPr>
-                <a:t>盲测 + 重复样；按信息增益评估</a:t>
-              </a:r>
-            </a:p>
-          </p:txBody>
-        </p:sp>
-        <p:sp>
-          <p:nvSpPr>
-            <p:cNvPr id="28" name="TextBox 28"/>
-            <p:cNvSpPr txBox="1"/>
-            <p:nvPr/>
-          </p:nvSpPr>
-          <p:spPr>
-            <a:xfrm>
-              <a:off x="6774942" y="4731068"/>
-              <a:ext cx="2739771" cy="264033"/>
-            </a:xfrm>
-            <a:prstGeom prst="rect">
-              <a:avLst/>
-            </a:prstGeom>
-            <a:noFill/>
-            <a:ln>
-              <a:noFill/>
-            </a:ln>
-          </p:spPr>
-          <p:txBody>
-            <a:bodyPr wrap="none" lIns="0" tIns="0" rIns="0" bIns="0" anchor="t" anchorCtr="0">
-              <a:spAutoFit/>
-            </a:bodyPr>
-            <a:lstStyle/>
-            <a:p>
-              <a:pPr algn="l"/>
-              <a:r>
-                <a:rPr lang="zh-CN" sz="1350" dirty="0">
-                  <a:solidFill>
-                    <a:schemeClr val="dk2"/>
-                  </a:solidFill>
-                  <a:latin typeface="Segoe UI"/>
-                  <a:ea typeface="Microsoft YaHei"/>
-                  <a:cs typeface="Segoe UI"/>
-                </a:rPr>
-                <a:t>控制假阳性，不让模型置信度自证</a:t>
-              </a:r>
-            </a:p>
-          </p:txBody>
-        </p:sp>
-        <p:sp>
-          <p:nvSpPr>
-            <p:cNvPr id="29" name="Line 29"/>
+                <a:t>位点 / 价态探针；Co 需联测氧分压与烧后价态</a:t>
+              </a:r>
+            </a:p>
+          </p:txBody>
+        </p:sp>
+        <p:sp>
+          <p:nvSpPr>
+            <p:cNvPr id="27" name="Line 27"/>
             <p:cNvSpPr/>
             <p:nvPr/>
           </p:nvSpPr>
@@ -24289,14 +25093,14 @@
         </p:sp>
         <p:sp>
           <p:nvSpPr>
-            <p:cNvPr id="30" name="TextBox 30"/>
-            <p:cNvSpPr txBox="1"/>
-            <p:nvPr/>
-          </p:nvSpPr>
-          <p:spPr>
-            <a:xfrm>
-              <a:off x="6432042" y="5340668"/>
-              <a:ext cx="3957066" cy="683133"/>
+            <p:cNvPr id="28" name="TextBox 28"/>
+            <p:cNvSpPr txBox="1"/>
+            <p:nvPr/>
+          </p:nvSpPr>
+          <p:spPr>
+            <a:xfrm>
+              <a:off x="6432042" y="5378768"/>
+              <a:ext cx="4600004" cy="759333"/>
             </a:xfrm>
             <a:prstGeom prst="rect">
               <a:avLst/>
@@ -24312,7 +25116,7 @@
             <a:p>
               <a:pPr algn="l">
                 <a:lnSpc>
-                  <a:spcPts val="1650"/>
+                  <a:spcPts val="1950"/>
                 </a:lnSpc>
               </a:pPr>
               <a:r>
@@ -24335,7 +25139,7 @@
                   <a:ea typeface="Microsoft YaHei"/>
                   <a:cs typeface="Segoe UI"/>
                 </a:rPr>
-                <a:t xml:space="preserve"> 氧化物 / 碳酸盐基线；</a:t>
+                <a:t xml:space="preserve"> Zn：ZnO + Y2O3 + SiO2 + BaCO3 </a:t>
               </a:r>
               <a:r>
                 <a:rPr lang="zh-CN" sz="1350" dirty="0">
@@ -24346,7 +25150,7 @@
                   <a:ea typeface="Microsoft YaHei"/>
                   <a:cs typeface="Segoe UI"/>
                 </a:rPr>
-                <a:t>其他路线只作对照，不作为目标相阳性证据。</a:t>
+                <a:t xml:space="preserve">Mg：MgO + Y2O3 + BaCO3 + SiO2 </a:t>
               </a:r>
               <a:r>
                 <a:rPr lang="zh-CN" sz="1350" dirty="0">
@@ -24357,7 +25161,7 @@
                   <a:ea typeface="Microsoft YaHei"/>
                   <a:cs typeface="Segoe UI"/>
                 </a:rPr>
-                <a:t>这里只定义测量问题与判据，不给出实验操作规程。</a:t>
+                <a:t>Co：Co3O4 + Y2O3 + BaCO3 + SiO2</a:t>
               </a:r>
             </a:p>
           </p:txBody>
@@ -24365,7 +25169,7 @@
       </p:grpSp>
       <p:grpSp>
         <p:nvGrpSpPr>
-          <p:cNvPr id="34" name="Group 34"/>
+          <p:cNvPr id="32" name="Group 32"/>
           <p:cNvGrpSpPr/>
           <p:nvPr/>
         </p:nvGrpSpPr>
@@ -24379,7 +25183,7 @@
         </p:grpSpPr>
         <p:sp>
           <p:nvSpPr>
-            <p:cNvPr id="32" name="TextBox 32"/>
+            <p:cNvPr id="30" name="TextBox 30"/>
             <p:cNvSpPr txBox="1"/>
             <p:nvPr/>
           </p:nvSpPr>
@@ -24419,7 +25223,7 @@
         </p:sp>
         <p:sp>
           <p:nvSpPr>
-            <p:cNvPr id="33" name="TextBox 33"/>
+            <p:cNvPr id="31" name="TextBox 31"/>
             <p:cNvSpPr txBox="1"/>
             <p:nvPr/>
           </p:nvSpPr>

</xml_diff>